<commit_message>
Week 7: review homework answers; fix radar speed meaning; camera-only table by default
- Observatory table defaults to objects in the front camera (toggle for all around)
- Radar speed column is the object's own speed (ego speed already subtracted);
  q10/q11 wording and explanation updated (ego at ~9 km/h in the rain scene)
- q4/q5 hints, f5/f7 explanations, L3 slides 10/12/15 notes, handouts synced

Co-Authored-By: Claude Opus 5.5 <noreply@anthropic.com>
</commit_message>
<xml_diff>
--- a/第七週(10-22)/第七週_第3節_簡報.pptx
+++ b/第七週(10-22)/第七週_第3節_簡報.pptx
@@ -686,11 +686,11 @@
                 <a:spcPts val="0"/>
               </a:spcBef>
               <a:spcAft>
-                <a:spcPts val="175"/>
+                <a:spcPts val="158"/>
               </a:spcAft>
             </a:pPr>
             <a:r>
-              <a:rPr sz="1050" b="1" lang="zh-TW" dirty="0">
+              <a:rPr sz="950" b="1" lang="zh-TW" dirty="0">
                 <a:solidFill>
                   <a:srgbClr val="000000"/>
                 </a:solidFill>
@@ -701,15 +701,15 @@
               <a:t>這一張的目的：</a:t>
             </a:r>
             <a:r>
-              <a:rPr sz="1050" lang="zh-TW" dirty="0">
-                <a:solidFill>
-                  <a:srgbClr val="000000"/>
-                </a:solidFill>
-                <a:latin typeface="Arial Unicode MS"/>
-                <a:ea typeface="Arial Unicode MS"/>
-                <a:cs typeface="Arial Unicode MS"/>
-              </a:rPr>
-              <a:t>教大家怎麼用觀察台，尤其是表格最右邊「前方相機畫面」那一欄：只數有 ● 的那幾列。
+              <a:rPr sz="950" lang="zh-TW" dirty="0">
+                <a:solidFill>
+                  <a:srgbClr val="000000"/>
+                </a:solidFill>
+                <a:latin typeface="Arial Unicode MS"/>
+                <a:ea typeface="Arial Unicode MS"/>
+                <a:cs typeface="Arial Unicode MS"/>
+              </a:rPr>
+              <a:t>教大家怎麼用觀察台，尤其是表格上方那兩個鈕：「只看前方相機畫面裡的」和「周圍一圈全部」。
 </a:t>
             </a:r>
           </a:p>
@@ -719,11 +719,11 @@
                 <a:spcPts val="0"/>
               </a:spcBef>
               <a:spcAft>
-                <a:spcPts val="175"/>
+                <a:spcPts val="158"/>
               </a:spcAft>
             </a:pPr>
             <a:r>
-              <a:rPr sz="1050" lang="zh-TW" dirty="0">
+              <a:rPr sz="950" lang="zh-TW" dirty="0">
                 <a:solidFill>
                   <a:srgbClr val="000000"/>
                 </a:solidFill>
@@ -741,11 +741,11 @@
                 <a:spcPts val="0"/>
               </a:spcBef>
               <a:spcAft>
-                <a:spcPts val="175"/>
+                <a:spcPts val="158"/>
               </a:spcAft>
             </a:pPr>
             <a:r>
-              <a:rPr sz="1050" b="1" lang="zh-TW" dirty="0">
+              <a:rPr sz="950" b="1" lang="zh-TW" dirty="0">
                 <a:solidFill>
                   <a:srgbClr val="000000"/>
                 </a:solidFill>
@@ -756,7 +756,7 @@
               <a:t>最上面，四個場景鈕</a:t>
             </a:r>
             <a:r>
-              <a:rPr sz="1050" lang="zh-TW" dirty="0">
+              <a:rPr sz="950" lang="zh-TW" dirty="0">
                 <a:solidFill>
                   <a:srgbClr val="000000"/>
                 </a:solidFill>
@@ -774,11 +774,11 @@
                 <a:spcPts val="0"/>
               </a:spcBef>
               <a:spcAft>
-                <a:spcPts val="175"/>
+                <a:spcPts val="158"/>
               </a:spcAft>
             </a:pPr>
             <a:r>
-              <a:rPr sz="1050" b="1" lang="zh-TW" dirty="0">
+              <a:rPr sz="950" b="1" lang="zh-TW" dirty="0">
                 <a:solidFill>
                   <a:srgbClr val="000000"/>
                 </a:solidFill>
@@ -789,7 +789,7 @@
               <a:t>左上，四個開關</a:t>
             </a:r>
             <a:r>
-              <a:rPr sz="1050" lang="zh-TW" dirty="0">
+              <a:rPr sz="950" lang="zh-TW" dirty="0">
                 <a:solidFill>
                   <a:srgbClr val="000000"/>
                 </a:solidFill>
@@ -807,11 +807,11 @@
                 <a:spcPts val="0"/>
               </a:spcBef>
               <a:spcAft>
-                <a:spcPts val="175"/>
+                <a:spcPts val="158"/>
               </a:spcAft>
             </a:pPr>
             <a:r>
-              <a:rPr sz="1050" lang="zh-TW" dirty="0">
+              <a:rPr sz="950" lang="zh-TW" dirty="0">
                 <a:solidFill>
                   <a:srgbClr val="000000"/>
                 </a:solidFill>
@@ -822,7 +822,7 @@
               <a:t>先講顏色。</a:t>
             </a:r>
             <a:r>
-              <a:rPr sz="1050" b="1" lang="zh-TW" dirty="0">
+              <a:rPr sz="950" b="1" lang="zh-TW" dirty="0">
                 <a:solidFill>
                   <a:srgbClr val="000000"/>
                 </a:solidFill>
@@ -833,7 +833,7 @@
               <a:t>光達點</a:t>
             </a:r>
             <a:r>
-              <a:rPr sz="1050" lang="zh-TW" dirty="0">
+              <a:rPr sz="950" lang="zh-TW" dirty="0">
                 <a:solidFill>
                   <a:srgbClr val="000000"/>
                 </a:solidFill>
@@ -844,7 +844,7 @@
               <a:t>是小方點，顏色代表距離，紅色近、藍色遠，跟第一節的圖一樣。</a:t>
             </a:r>
             <a:r>
-              <a:rPr sz="1050" b="1" lang="zh-TW" dirty="0">
+              <a:rPr sz="950" b="1" lang="zh-TW" dirty="0">
                 <a:solidFill>
                   <a:srgbClr val="000000"/>
                 </a:solidFill>
@@ -855,7 +855,7 @@
               <a:t>雷達點</a:t>
             </a:r>
             <a:r>
-              <a:rPr sz="1050" lang="zh-TW" dirty="0">
+              <a:rPr sz="950" lang="zh-TW" dirty="0">
                 <a:solidFill>
                   <a:srgbClr val="000000"/>
                 </a:solidFill>
@@ -866,7 +866,7 @@
               <a:t>是圓圈，顏色也照距離：紅色近、藍色遠；實心的表示那個東西在動，空心的表示靜止。為什麼雷達圈也要照距離上色？因為雷達量不出高度，遠處的點畫到照片上會疊到近處的框裡，看顏色才知道它其實在多遠。</a:t>
             </a:r>
             <a:r>
-              <a:rPr sz="1050" b="1" lang="zh-TW" dirty="0">
+              <a:rPr sz="950" b="1" lang="zh-TW" dirty="0">
                 <a:solidFill>
                   <a:srgbClr val="000000"/>
                 </a:solidFill>
@@ -877,7 +877,7 @@
               <a:t>物體框</a:t>
             </a:r>
             <a:r>
-              <a:rPr sz="1050" lang="zh-TW" dirty="0">
+              <a:rPr sz="950" lang="zh-TW" dirty="0">
                 <a:solidFill>
                   <a:srgbClr val="000000"/>
                 </a:solidFill>
@@ -888,7 +888,7 @@
               <a:t>有兩種顏色：</a:t>
             </a:r>
             <a:r>
-              <a:rPr sz="1050" b="1" lang="zh-TW" dirty="0">
+              <a:rPr sz="950" b="1" lang="zh-TW" dirty="0">
                 <a:solidFill>
                   <a:srgbClr val="000000"/>
                 </a:solidFill>
@@ -899,7 +899,7 @@
               <a:t>綠框表示框裡至少有一個雷達點，橘框表示一個都沒有。</a:t>
             </a:r>
             <a:r>
-              <a:rPr sz="1050" lang="zh-TW" dirty="0">
+              <a:rPr sz="950" lang="zh-TW" dirty="0">
                 <a:solidFill>
                   <a:srgbClr val="000000"/>
                 </a:solidFill>
@@ -917,11 +917,11 @@
                 <a:spcPts val="0"/>
               </a:spcBef>
               <a:spcAft>
-                <a:spcPts val="175"/>
+                <a:spcPts val="158"/>
               </a:spcAft>
             </a:pPr>
             <a:r>
-              <a:rPr sz="1050" lang="zh-TW" dirty="0">
+              <a:rPr sz="950" lang="zh-TW" dirty="0">
                 <a:solidFill>
                   <a:srgbClr val="000000"/>
                 </a:solidFill>
@@ -939,11 +939,11 @@
                 <a:spcPts val="0"/>
               </a:spcBef>
               <a:spcAft>
-                <a:spcPts val="175"/>
+                <a:spcPts val="158"/>
               </a:spcAft>
             </a:pPr>
             <a:r>
-              <a:rPr sz="1050" b="1" lang="zh-TW" dirty="0">
+              <a:rPr sz="950" b="1" lang="zh-TW" dirty="0">
                 <a:solidFill>
                   <a:srgbClr val="000000"/>
                 </a:solidFill>
@@ -954,7 +954,7 @@
               <a:t>右邊，數一數。</a:t>
             </a:r>
             <a:r>
-              <a:rPr sz="1050" lang="zh-TW" dirty="0">
+              <a:rPr sz="950" lang="zh-TW" dirty="0">
                 <a:solidFill>
                   <a:srgbClr val="000000"/>
                 </a:solidFill>
@@ -965,7 +965,7 @@
               <a:t>上面三格數字：畫面裡有幾個光達點、幾個雷達點、幾個物體有被雷達抓到。下面的表格，每一列是一個物體，寫它離車子多遠、身上有幾個光達點、幾個雷達點，還有一欄「</a:t>
             </a:r>
             <a:r>
-              <a:rPr sz="1050" b="1" lang="zh-TW" dirty="0">
+              <a:rPr sz="950" b="1" lang="zh-TW" dirty="0">
                 <a:solidFill>
                   <a:srgbClr val="000000"/>
                 </a:solidFill>
@@ -976,15 +976,37 @@
               <a:t>雷達：多快</a:t>
             </a:r>
             <a:r>
-              <a:rPr sz="1050" lang="zh-TW" dirty="0">
-                <a:solidFill>
-                  <a:srgbClr val="000000"/>
-                </a:solidFill>
-                <a:latin typeface="Arial Unicode MS"/>
-                <a:ea typeface="Arial Unicode MS"/>
-                <a:cs typeface="Arial Unicode MS"/>
-              </a:rPr>
-              <a:t>」：雷達量到這個東西正在靠近還是遠離、時速多少。沒有雷達點的，這一欄就是一條線。
+              <a:rPr sz="950" lang="zh-TW" dirty="0">
+                <a:solidFill>
+                  <a:srgbClr val="000000"/>
+                </a:solidFill>
+                <a:latin typeface="Arial Unicode MS"/>
+                <a:ea typeface="Arial Unicode MS"/>
+                <a:cs typeface="Arial Unicode MS"/>
+              </a:rPr>
+              <a:t>」：這個東西</a:t>
+            </a:r>
+            <a:r>
+              <a:rPr sz="950" b="1" lang="zh-TW" dirty="0">
+                <a:solidFill>
+                  <a:srgbClr val="000000"/>
+                </a:solidFill>
+                <a:latin typeface="Arial Unicode MS"/>
+                <a:ea typeface="Arial Unicode MS"/>
+                <a:cs typeface="Arial Unicode MS"/>
+              </a:rPr>
+              <a:t>自己</a:t>
+            </a:r>
+            <a:r>
+              <a:rPr sz="950" lang="zh-TW" dirty="0">
+                <a:solidFill>
+                  <a:srgbClr val="000000"/>
+                </a:solidFill>
+                <a:latin typeface="Arial Unicode MS"/>
+                <a:ea typeface="Arial Unicode MS"/>
+                <a:cs typeface="Arial Unicode MS"/>
+              </a:rPr>
+              <a:t>在路上走多快，往我們這邊來寫「靠近」，往遠處去寫「遠離」。第一節講過，雷達會把量到的速度扣掉自己的車速；nuScenes 的資料已經扣好了，所以停著的車寫 ≈0，就算我們的車正在開也一樣。沒有雷達點的，這一欄就是一條線。偶爾會看到「有雷達點、速度卻是一條線」，那是因為那個點被官方的過濾條件拿掉了，只算點數、不畫在圖上。
 </a:t>
             </a:r>
           </a:p>
@@ -994,30 +1016,74 @@
                 <a:spcPts val="0"/>
               </a:spcBef>
               <a:spcAft>
-                <a:spcPts val="175"/>
+                <a:spcPts val="158"/>
               </a:spcAft>
             </a:pPr>
             <a:r>
-              <a:rPr sz="1050" b="1" lang="zh-TW" dirty="0">
-                <a:solidFill>
-                  <a:srgbClr val="000000"/>
-                </a:solidFill>
-                <a:latin typeface="Arial Unicode MS"/>
-                <a:ea typeface="Arial Unicode MS"/>
-                <a:cs typeface="Arial Unicode MS"/>
-              </a:rPr>
-              <a:t>第四個開關「合起來」</a:t>
-            </a:r>
-            <a:r>
-              <a:rPr sz="1050" lang="zh-TW" dirty="0">
-                <a:solidFill>
-                  <a:srgbClr val="000000"/>
-                </a:solidFill>
-                <a:latin typeface="Arial Unicode MS"/>
-                <a:ea typeface="Arial Unicode MS"/>
-                <a:cs typeface="Arial Unicode MS"/>
-              </a:rPr>
-              <a:t>，會在每個框上寫一行字，例如「車・12 m・遠離 18」：「車」是相機認出來的，「12 m」是光達量的，「遠離 18」是雷達量的速度。三種感測器各給一塊，拼成一句話。任務五會用到。
+              <a:rPr sz="950" b="1" lang="zh-TW" dirty="0">
+                <a:solidFill>
+                  <a:srgbClr val="000000"/>
+                </a:solidFill>
+                <a:latin typeface="Arial Unicode MS"/>
+                <a:ea typeface="Arial Unicode MS"/>
+                <a:cs typeface="Arial Unicode MS"/>
+              </a:rPr>
+              <a:t>表格上方有兩個鈕。</a:t>
+            </a:r>
+            <a:r>
+              <a:rPr sz="950" lang="zh-TW" dirty="0">
+                <a:solidFill>
+                  <a:srgbClr val="000000"/>
+                </a:solidFill>
+                <a:latin typeface="Arial Unicode MS"/>
+                <a:ea typeface="Arial Unicode MS"/>
+                <a:cs typeface="Arial Unicode MS"/>
+              </a:rPr>
+              <a:t>預設是「</a:t>
+            </a:r>
+            <a:r>
+              <a:rPr sz="950" b="1" lang="zh-TW" dirty="0">
+                <a:solidFill>
+                  <a:srgbClr val="000000"/>
+                </a:solidFill>
+                <a:latin typeface="Arial Unicode MS"/>
+                <a:ea typeface="Arial Unicode MS"/>
+                <a:cs typeface="Arial Unicode MS"/>
+              </a:rPr>
+              <a:t>只看前方相機畫面裡的</a:t>
+            </a:r>
+            <a:r>
+              <a:rPr sz="950" lang="zh-TW" dirty="0">
+                <a:solidFill>
+                  <a:srgbClr val="000000"/>
+                </a:solidFill>
+                <a:latin typeface="Arial Unicode MS"/>
+                <a:ea typeface="Arial Unicode MS"/>
+                <a:cs typeface="Arial Unicode MS"/>
+              </a:rPr>
+              <a:t>」，表格只列照片裡看得到的物體，今天的作業都問照片裡的東西，用這個就好。另一個是「</a:t>
+            </a:r>
+            <a:r>
+              <a:rPr sz="950" b="1" lang="zh-TW" dirty="0">
+                <a:solidFill>
+                  <a:srgbClr val="000000"/>
+                </a:solidFill>
+                <a:latin typeface="Arial Unicode MS"/>
+                <a:ea typeface="Arial Unicode MS"/>
+                <a:cs typeface="Arial Unicode MS"/>
+              </a:rPr>
+              <a:t>周圍一圈全部</a:t>
+            </a:r>
+            <a:r>
+              <a:rPr sz="950" lang="zh-TW" dirty="0">
+                <a:solidFill>
+                  <a:srgbClr val="000000"/>
+                </a:solidFill>
+                <a:latin typeface="Arial Unicode MS"/>
+                <a:ea typeface="Arial Unicode MS"/>
+                <a:cs typeface="Arial Unicode MS"/>
+              </a:rPr>
+              <a:t>」，會把車子旁邊、後面五十公尺內的物體都列出來，最右邊那一欄寫它在車子的哪一邊。停車場切到全部會有六十幾列，很容易漏看，所以預設不開。
 </a:t>
             </a:r>
           </a:p>
@@ -1027,74 +1093,30 @@
                 <a:spcPts val="0"/>
               </a:spcBef>
               <a:spcAft>
-                <a:spcPts val="175"/>
+                <a:spcPts val="158"/>
               </a:spcAft>
             </a:pPr>
             <a:r>
-              <a:rPr sz="1050" b="1" lang="zh-TW" dirty="0">
-                <a:solidFill>
-                  <a:srgbClr val="000000"/>
-                </a:solidFill>
-                <a:latin typeface="Arial Unicode MS"/>
-                <a:ea typeface="Arial Unicode MS"/>
-                <a:cs typeface="Arial Unicode MS"/>
-              </a:rPr>
-              <a:t>這裡最容易搞錯，請看結論條。</a:t>
-            </a:r>
-            <a:r>
-              <a:rPr sz="1050" lang="zh-TW" dirty="0">
-                <a:solidFill>
-                  <a:srgbClr val="000000"/>
-                </a:solidFill>
-                <a:latin typeface="Arial Unicode MS"/>
-                <a:ea typeface="Arial Unicode MS"/>
-                <a:cs typeface="Arial Unicode MS"/>
-              </a:rPr>
-              <a:t>表格列的是車子周圍五十公尺內</a:t>
-            </a:r>
-            <a:r>
-              <a:rPr sz="1050" b="1" lang="zh-TW" dirty="0">
-                <a:solidFill>
-                  <a:srgbClr val="000000"/>
-                </a:solidFill>
-                <a:latin typeface="Arial Unicode MS"/>
-                <a:ea typeface="Arial Unicode MS"/>
-                <a:cs typeface="Arial Unicode MS"/>
-              </a:rPr>
-              <a:t>全部</a:t>
-            </a:r>
-            <a:r>
-              <a:rPr sz="1050" lang="zh-TW" dirty="0">
-                <a:solidFill>
-                  <a:srgbClr val="000000"/>
-                </a:solidFill>
-                <a:latin typeface="Arial Unicode MS"/>
-                <a:ea typeface="Arial Unicode MS"/>
-                <a:cs typeface="Arial Unicode MS"/>
-              </a:rPr>
-              <a:t>的物體，連車子後面的也列進來。所以題目問「前方相機畫面裡」的時候，</a:t>
-            </a:r>
-            <a:r>
-              <a:rPr sz="1050" b="1" lang="zh-TW" dirty="0">
-                <a:solidFill>
-                  <a:srgbClr val="000000"/>
-                </a:solidFill>
-                <a:latin typeface="Arial Unicode MS"/>
-                <a:ea typeface="Arial Unicode MS"/>
-                <a:cs typeface="Arial Unicode MS"/>
-              </a:rPr>
-              <a:t>只數表格最右邊「前方相機畫面」那一欄，有一個黑色圓點 ● 的那幾列</a:t>
-            </a:r>
-            <a:r>
-              <a:rPr sz="1050" lang="zh-TW" dirty="0">
-                <a:solidFill>
-                  <a:srgbClr val="000000"/>
-                </a:solidFill>
-                <a:latin typeface="Arial Unicode MS"/>
-                <a:ea typeface="Arial Unicode MS"/>
-                <a:cs typeface="Arial Unicode MS"/>
-              </a:rPr>
-              <a:t>；沒有 ● 的，那一欄會寫它在車子的左側、右側還是後方。nuScenes 的車一圈有六台相機，觀察台只放正前方那一台。停車場那個場景，表格裡的車有三十幾台，畫面裡只有四台。
+              <a:rPr sz="950" b="1" lang="zh-TW" dirty="0">
+                <a:solidFill>
+                  <a:srgbClr val="000000"/>
+                </a:solidFill>
+                <a:latin typeface="Arial Unicode MS"/>
+                <a:ea typeface="Arial Unicode MS"/>
+                <a:cs typeface="Arial Unicode MS"/>
+              </a:rPr>
+              <a:t>第四個開關「合起來」</a:t>
+            </a:r>
+            <a:r>
+              <a:rPr sz="950" lang="zh-TW" dirty="0">
+                <a:solidFill>
+                  <a:srgbClr val="000000"/>
+                </a:solidFill>
+                <a:latin typeface="Arial Unicode MS"/>
+                <a:ea typeface="Arial Unicode MS"/>
+                <a:cs typeface="Arial Unicode MS"/>
+              </a:rPr>
+              <a:t>，會在每個框上寫一行字，例如「車・12 m・遠離 18」：「車」是相機認出來的，「12 m」是光達量的，「遠離 18」是雷達量的、那台車自己的速度。三種感測器各給一塊，拼成一句話。任務五會用到。
 </a:t>
             </a:r>
           </a:p>
@@ -1104,41 +1126,74 @@
                 <a:spcPts val="0"/>
               </a:spcBef>
               <a:spcAft>
-                <a:spcPts val="175"/>
+                <a:spcPts val="158"/>
               </a:spcAft>
             </a:pPr>
             <a:r>
-              <a:rPr sz="1050" lang="zh-TW" dirty="0">
-                <a:solidFill>
-                  <a:srgbClr val="000000"/>
-                </a:solidFill>
-                <a:latin typeface="Arial Unicode MS"/>
-                <a:ea typeface="Arial Unicode MS"/>
-                <a:cs typeface="Arial Unicode MS"/>
-              </a:rPr>
-              <a:t>也提醒一句：這一欄</a:t>
-            </a:r>
-            <a:r>
-              <a:rPr sz="1050" b="1" lang="zh-TW" dirty="0">
-                <a:solidFill>
-                  <a:srgbClr val="000000"/>
-                </a:solidFill>
-                <a:latin typeface="Arial Unicode MS"/>
-                <a:ea typeface="Arial Unicode MS"/>
-                <a:cs typeface="Arial Unicode MS"/>
-              </a:rPr>
-              <a:t>不是「相機有沒有認出來」</a:t>
-            </a:r>
-            <a:r>
-              <a:rPr sz="1050" lang="zh-TW" dirty="0">
-                <a:solidFill>
-                  <a:srgbClr val="000000"/>
-                </a:solidFill>
-                <a:latin typeface="Arial Unicode MS"/>
-                <a:ea typeface="Arial Unicode MS"/>
-                <a:cs typeface="Arial Unicode MS"/>
-              </a:rPr>
-              <a:t>。框是人工畫的標註，那個 ● 只表示那個東西在前方相機拍得到的範圍裡。
+              <a:rPr sz="950" b="1" lang="zh-TW" dirty="0">
+                <a:solidFill>
+                  <a:srgbClr val="000000"/>
+                </a:solidFill>
+                <a:latin typeface="Arial Unicode MS"/>
+                <a:ea typeface="Arial Unicode MS"/>
+                <a:cs typeface="Arial Unicode MS"/>
+              </a:rPr>
+              <a:t>這裡最容易搞錯，請看結論條。</a:t>
+            </a:r>
+            <a:r>
+              <a:rPr sz="950" lang="zh-TW" dirty="0">
+                <a:solidFill>
+                  <a:srgbClr val="000000"/>
+                </a:solidFill>
+                <a:latin typeface="Arial Unicode MS"/>
+                <a:ea typeface="Arial Unicode MS"/>
+                <a:cs typeface="Arial Unicode MS"/>
+              </a:rPr>
+              <a:t>表格列的是車子周圍五十公尺內</a:t>
+            </a:r>
+            <a:r>
+              <a:rPr sz="950" b="1" lang="zh-TW" dirty="0">
+                <a:solidFill>
+                  <a:srgbClr val="000000"/>
+                </a:solidFill>
+                <a:latin typeface="Arial Unicode MS"/>
+                <a:ea typeface="Arial Unicode MS"/>
+                <a:cs typeface="Arial Unicode MS"/>
+              </a:rPr>
+              <a:t>全部</a:t>
+            </a:r>
+            <a:r>
+              <a:rPr sz="950" lang="zh-TW" dirty="0">
+                <a:solidFill>
+                  <a:srgbClr val="000000"/>
+                </a:solidFill>
+                <a:latin typeface="Arial Unicode MS"/>
+                <a:ea typeface="Arial Unicode MS"/>
+                <a:cs typeface="Arial Unicode MS"/>
+              </a:rPr>
+              <a:t>的物體，連車子後面的也列進來。所以題目問「前方相機畫面裡」的時候，</a:t>
+            </a:r>
+            <a:r>
+              <a:rPr sz="950" b="1" lang="zh-TW" dirty="0">
+                <a:solidFill>
+                  <a:srgbClr val="000000"/>
+                </a:solidFill>
+                <a:latin typeface="Arial Unicode MS"/>
+                <a:ea typeface="Arial Unicode MS"/>
+                <a:cs typeface="Arial Unicode MS"/>
+              </a:rPr>
+              <a:t>只數表格最右邊「前方相機畫面」那一欄，有一個黑色圓點 ● 的那幾列</a:t>
+            </a:r>
+            <a:r>
+              <a:rPr sz="950" lang="zh-TW" dirty="0">
+                <a:solidFill>
+                  <a:srgbClr val="000000"/>
+                </a:solidFill>
+                <a:latin typeface="Arial Unicode MS"/>
+                <a:ea typeface="Arial Unicode MS"/>
+                <a:cs typeface="Arial Unicode MS"/>
+              </a:rPr>
+              <a:t>；沒有 ● 的，那一欄會寫它在車子的左側、右側還是後方。nuScenes 的車一圈有六台相機，觀察台只放正前方那一台。停車場那個場景，表格裡的車有三十幾台，畫面裡只有四台。
 </a:t>
             </a:r>
           </a:p>
@@ -1148,11 +1203,55 @@
                 <a:spcPts val="0"/>
               </a:spcBef>
               <a:spcAft>
-                <a:spcPts val="175"/>
+                <a:spcPts val="158"/>
               </a:spcAft>
             </a:pPr>
             <a:r>
-              <a:rPr sz="1050" lang="zh-TW" dirty="0">
+              <a:rPr sz="950" lang="zh-TW" dirty="0">
+                <a:solidFill>
+                  <a:srgbClr val="000000"/>
+                </a:solidFill>
+                <a:latin typeface="Arial Unicode MS"/>
+                <a:ea typeface="Arial Unicode MS"/>
+                <a:cs typeface="Arial Unicode MS"/>
+              </a:rPr>
+              <a:t>也提醒一句：這一欄</a:t>
+            </a:r>
+            <a:r>
+              <a:rPr sz="950" b="1" lang="zh-TW" dirty="0">
+                <a:solidFill>
+                  <a:srgbClr val="000000"/>
+                </a:solidFill>
+                <a:latin typeface="Arial Unicode MS"/>
+                <a:ea typeface="Arial Unicode MS"/>
+                <a:cs typeface="Arial Unicode MS"/>
+              </a:rPr>
+              <a:t>不是「相機有沒有認出來」</a:t>
+            </a:r>
+            <a:r>
+              <a:rPr sz="950" lang="zh-TW" dirty="0">
+                <a:solidFill>
+                  <a:srgbClr val="000000"/>
+                </a:solidFill>
+                <a:latin typeface="Arial Unicode MS"/>
+                <a:ea typeface="Arial Unicode MS"/>
+                <a:cs typeface="Arial Unicode MS"/>
+              </a:rPr>
+              <a:t>。框是人工畫的標註，那個 ● 只表示那個東西在前方相機拍得到的範圍裡。
+</a:t>
+            </a:r>
+          </a:p>
+          <a:p>
+            <a:pPr algn="l">
+              <a:spcBef>
+                <a:spcPts val="0"/>
+              </a:spcBef>
+              <a:spcAft>
+                <a:spcPts val="158"/>
+              </a:spcAft>
+            </a:pPr>
+            <a:r>
+              <a:rPr sz="950" lang="zh-TW" dirty="0">
                 <a:solidFill>
                   <a:srgbClr val="000000"/>
                 </a:solidFill>
@@ -1819,11 +1918,11 @@
                 <a:spcPts val="0"/>
               </a:spcBef>
               <a:spcAft>
-                <a:spcPts val="250"/>
+                <a:spcPts val="225"/>
               </a:spcAft>
             </a:pPr>
             <a:r>
-              <a:rPr sz="1500" b="1" lang="zh-TW" dirty="0">
+              <a:rPr sz="1350" b="1" lang="zh-TW" dirty="0">
                 <a:solidFill>
                   <a:srgbClr val="000000"/>
                 </a:solidFill>
@@ -1834,7 +1933,7 @@
               <a:t>這一張的目的：</a:t>
             </a:r>
             <a:r>
-              <a:rPr sz="1500" lang="zh-TW" dirty="0">
+              <a:rPr sz="1350" lang="zh-TW" dirty="0">
                 <a:solidFill>
                   <a:srgbClr val="000000"/>
                 </a:solidFill>
@@ -1852,11 +1951,11 @@
                 <a:spcPts val="0"/>
               </a:spcBef>
               <a:spcAft>
-                <a:spcPts val="250"/>
+                <a:spcPts val="225"/>
               </a:spcAft>
             </a:pPr>
             <a:r>
-              <a:rPr sz="1500" lang="zh-TW" dirty="0">
+              <a:rPr sz="1350" lang="zh-TW" dirty="0">
                 <a:solidFill>
                   <a:srgbClr val="000000"/>
                 </a:solidFill>
@@ -1867,7 +1966,7 @@
               <a:t>任務二，</a:t>
             </a:r>
             <a:r>
-              <a:rPr sz="1500" b="1" lang="zh-TW" dirty="0">
+              <a:rPr sz="1350" b="1" lang="zh-TW" dirty="0">
                 <a:solidFill>
                   <a:srgbClr val="000000"/>
                 </a:solidFill>
@@ -1878,7 +1977,7 @@
               <a:t>新加坡的一個停車場</a:t>
             </a:r>
             <a:r>
-              <a:rPr sz="1500" lang="zh-TW" dirty="0">
+              <a:rPr sz="1350" lang="zh-TW" dirty="0">
                 <a:solidFill>
                   <a:srgbClr val="000000"/>
                 </a:solidFill>
@@ -1896,41 +1995,63 @@
                 <a:spcPts val="0"/>
               </a:spcBef>
               <a:spcAft>
-                <a:spcPts val="250"/>
+                <a:spcPts val="225"/>
               </a:spcAft>
             </a:pPr>
             <a:r>
-              <a:rPr sz="1500" lang="zh-TW" dirty="0">
-                <a:solidFill>
-                  <a:srgbClr val="000000"/>
-                </a:solidFill>
-                <a:latin typeface="Arial Unicode MS"/>
-                <a:ea typeface="Arial Unicode MS"/>
-                <a:cs typeface="Arial Unicode MS"/>
-              </a:rPr>
-              <a:t>先提醒一次：這個場景表格很長，因為停車場裡到處都是車，三十幾台，大部分在車子旁邊和後面。</a:t>
-            </a:r>
-            <a:r>
-              <a:rPr sz="1500" b="1" lang="zh-TW" dirty="0">
-                <a:solidFill>
-                  <a:srgbClr val="000000"/>
-                </a:solidFill>
-                <a:latin typeface="Arial Unicode MS"/>
-                <a:ea typeface="Arial Unicode MS"/>
-                <a:cs typeface="Arial Unicode MS"/>
-              </a:rPr>
-              <a:t>只數表格最右邊「前方相機畫面」那一欄有 ● 的那幾列。</a:t>
-            </a:r>
-            <a:r>
-              <a:rPr sz="1500" lang="zh-TW" dirty="0">
-                <a:solidFill>
-                  <a:srgbClr val="000000"/>
-                </a:solidFill>
-                <a:latin typeface="Arial Unicode MS"/>
-                <a:ea typeface="Arial Unicode MS"/>
-                <a:cs typeface="Arial Unicode MS"/>
-              </a:rPr>
-              <a:t>
+              <a:rPr sz="1350" lang="zh-TW" dirty="0">
+                <a:solidFill>
+                  <a:srgbClr val="000000"/>
+                </a:solidFill>
+                <a:latin typeface="Arial Unicode MS"/>
+                <a:ea typeface="Arial Unicode MS"/>
+                <a:cs typeface="Arial Unicode MS"/>
+              </a:rPr>
+              <a:t>先提醒一次：表格上方的鈕要停在「</a:t>
+            </a:r>
+            <a:r>
+              <a:rPr sz="1350" b="1" lang="zh-TW" dirty="0">
+                <a:solidFill>
+                  <a:srgbClr val="000000"/>
+                </a:solidFill>
+                <a:latin typeface="Arial Unicode MS"/>
+                <a:ea typeface="Arial Unicode MS"/>
+                <a:cs typeface="Arial Unicode MS"/>
+              </a:rPr>
+              <a:t>只看前方相機畫面裡的</a:t>
+            </a:r>
+            <a:r>
+              <a:rPr sz="1350" lang="zh-TW" dirty="0">
+                <a:solidFill>
+                  <a:srgbClr val="000000"/>
+                </a:solidFill>
+                <a:latin typeface="Arial Unicode MS"/>
+                <a:ea typeface="Arial Unicode MS"/>
+                <a:cs typeface="Arial Unicode MS"/>
+              </a:rPr>
+              <a:t>」，這時表格有十七列：行人、機車、汽車混在一起，照距離排。表格框只顯示十一列左右，</a:t>
+            </a:r>
+            <a:r>
+              <a:rPr sz="1350" b="1" lang="zh-TW" dirty="0">
+                <a:solidFill>
+                  <a:srgbClr val="000000"/>
+                </a:solidFill>
+                <a:latin typeface="Arial Unicode MS"/>
+                <a:ea typeface="Arial Unicode MS"/>
+                <a:cs typeface="Arial Unicode MS"/>
+              </a:rPr>
+              <a:t>要往下捲到底</a:t>
+            </a:r>
+            <a:r>
+              <a:rPr sz="1350" lang="zh-TW" dirty="0">
+                <a:solidFill>
+                  <a:srgbClr val="000000"/>
+                </a:solidFill>
+                <a:latin typeface="Arial Unicode MS"/>
+                <a:ea typeface="Arial Unicode MS"/>
+                <a:cs typeface="Arial Unicode MS"/>
+              </a:rPr>
+              <a:t>，不然後面的汽車會漏掉。
 </a:t>
             </a:r>
           </a:p>
@@ -1940,11 +2061,11 @@
                 <a:spcPts val="0"/>
               </a:spcBef>
               <a:spcAft>
-                <a:spcPts val="250"/>
+                <a:spcPts val="225"/>
               </a:spcAft>
             </a:pPr>
             <a:r>
-              <a:rPr sz="1500" lang="zh-TW" dirty="0">
+              <a:rPr sz="1350" lang="zh-TW" dirty="0">
                 <a:solidFill>
                   <a:srgbClr val="000000"/>
                 </a:solidFill>
@@ -1962,11 +2083,11 @@
                 <a:spcPts val="0"/>
               </a:spcBef>
               <a:spcAft>
-                <a:spcPts val="250"/>
+                <a:spcPts val="225"/>
               </a:spcAft>
             </a:pPr>
             <a:r>
-              <a:rPr sz="1500" b="1" lang="zh-TW" dirty="0">
+              <a:rPr sz="1350" b="1" lang="zh-TW" dirty="0">
                 <a:solidFill>
                   <a:srgbClr val="000000"/>
                 </a:solidFill>
@@ -1977,7 +2098,7 @@
               <a:t>第 4 題。</a:t>
             </a:r>
             <a:r>
-              <a:rPr sz="1500" lang="zh-TW" dirty="0">
+              <a:rPr sz="1350" lang="zh-TW" dirty="0">
                 <a:solidFill>
                   <a:srgbClr val="000000"/>
                 </a:solidFill>
@@ -1988,7 +2109,7 @@
               <a:t>畫面裡八台機車，框大多是橘色。看表格，機車那幾列，雷達點不是零的只有兩台：十六點八公尺那台兩個點，二十一點八公尺有一台一個點。答案是 </a:t>
             </a:r>
             <a:r>
-              <a:rPr sz="1500" b="1" lang="zh-TW" dirty="0">
+              <a:rPr sz="1350" b="1" lang="zh-TW" dirty="0">
                 <a:solidFill>
                   <a:srgbClr val="000000"/>
                 </a:solidFill>
@@ -1999,7 +2120,7 @@
               <a:t>2 台</a:t>
             </a:r>
             <a:r>
-              <a:rPr sz="1500" lang="zh-TW" dirty="0">
+              <a:rPr sz="1350" lang="zh-TW" dirty="0">
                 <a:solidFill>
                   <a:srgbClr val="000000"/>
                 </a:solidFill>
@@ -2017,52 +2138,19 @@
                 <a:spcPts val="0"/>
               </a:spcBef>
               <a:spcAft>
-                <a:spcPts val="250"/>
+                <a:spcPts val="225"/>
               </a:spcAft>
             </a:pPr>
             <a:r>
-              <a:rPr sz="1500" b="1" lang="zh-TW" dirty="0">
-                <a:solidFill>
-                  <a:srgbClr val="000000"/>
-                </a:solidFill>
-                <a:latin typeface="Arial Unicode MS"/>
-                <a:ea typeface="Arial Unicode MS"/>
-                <a:cs typeface="Arial Unicode MS"/>
-              </a:rPr>
-              <a:t>第 5 題。</a:t>
-            </a:r>
-            <a:r>
-              <a:rPr sz="1500" lang="zh-TW" dirty="0">
-                <a:solidFill>
-                  <a:srgbClr val="000000"/>
-                </a:solidFill>
-                <a:latin typeface="Arial Unicode MS"/>
-                <a:ea typeface="Arial Unicode MS"/>
-                <a:cs typeface="Arial Unicode MS"/>
-              </a:rPr>
-              <a:t>右邊那幾台汽車，二十七到二十九公尺，四台框都是綠色，每台兩到三個雷達點，只有一台是一個點。答案是 </a:t>
-            </a:r>
-            <a:r>
-              <a:rPr sz="1500" b="1" lang="zh-TW" dirty="0">
-                <a:solidFill>
-                  <a:srgbClr val="000000"/>
-                </a:solidFill>
-                <a:latin typeface="Arial Unicode MS"/>
-                <a:ea typeface="Arial Unicode MS"/>
-                <a:cs typeface="Arial Unicode MS"/>
-              </a:rPr>
-              <a:t>4 台</a:t>
-            </a:r>
-            <a:r>
-              <a:rPr sz="1500" lang="zh-TW" dirty="0">
-                <a:solidFill>
-                  <a:srgbClr val="000000"/>
-                </a:solidFill>
-                <a:latin typeface="Arial Unicode MS"/>
-                <a:ea typeface="Arial Unicode MS"/>
-                <a:cs typeface="Arial Unicode MS"/>
-              </a:rPr>
-              <a:t>。
+              <a:rPr sz="1350" lang="zh-TW" dirty="0">
+                <a:solidFill>
+                  <a:srgbClr val="000000"/>
+                </a:solidFill>
+                <a:latin typeface="Arial Unicode MS"/>
+                <a:ea typeface="Arial Unicode MS"/>
+                <a:cs typeface="Arial Unicode MS"/>
+              </a:rPr>
+              <a:t>有同學可能只看到一台：二十一點八公尺那台的「雷達：多快」是一條線，看起來像沒有。它其實有一個點，只是這個點被官方的過濾條件拿掉了，所以算點數、沒有速度。另一台十六點八公尺的在表格比較上面，要往回捲才看得到。
 </a:t>
             </a:r>
           </a:p>
@@ -2072,41 +2160,52 @@
                 <a:spcPts val="0"/>
               </a:spcBef>
               <a:spcAft>
-                <a:spcPts val="250"/>
+                <a:spcPts val="225"/>
               </a:spcAft>
             </a:pPr>
             <a:r>
-              <a:rPr sz="1500" lang="zh-TW" dirty="0">
-                <a:solidFill>
-                  <a:srgbClr val="000000"/>
-                </a:solidFill>
-                <a:latin typeface="Arial Unicode MS"/>
-                <a:ea typeface="Arial Unicode MS"/>
-                <a:cs typeface="Arial Unicode MS"/>
-              </a:rPr>
-              <a:t>兩題放在一起看：</a:t>
-            </a:r>
-            <a:r>
-              <a:rPr sz="1500" b="1" lang="zh-TW" dirty="0">
-                <a:solidFill>
-                  <a:srgbClr val="000000"/>
-                </a:solidFill>
-                <a:latin typeface="Arial Unicode MS"/>
-                <a:ea typeface="Arial Unicode MS"/>
-                <a:cs typeface="Arial Unicode MS"/>
-              </a:rPr>
-              <a:t>機車比汽車近，雷達反而抓不太到。</a:t>
-            </a:r>
-            <a:r>
-              <a:rPr sz="1500" lang="zh-TW" dirty="0">
-                <a:solidFill>
-                  <a:srgbClr val="000000"/>
-                </a:solidFill>
-                <a:latin typeface="Arial Unicode MS"/>
-                <a:ea typeface="Arial Unicode MS"/>
-                <a:cs typeface="Arial Unicode MS"/>
-              </a:rPr>
-              <a:t>汽車是一大塊金屬，像一面鏡子；機車小，很多部分是塑膠，人坐在上面，電波回來很弱。
+              <a:rPr sz="1350" b="1" lang="zh-TW" dirty="0">
+                <a:solidFill>
+                  <a:srgbClr val="000000"/>
+                </a:solidFill>
+                <a:latin typeface="Arial Unicode MS"/>
+                <a:ea typeface="Arial Unicode MS"/>
+                <a:cs typeface="Arial Unicode MS"/>
+              </a:rPr>
+              <a:t>第 5 題。</a:t>
+            </a:r>
+            <a:r>
+              <a:rPr sz="1350" lang="zh-TW" dirty="0">
+                <a:solidFill>
+                  <a:srgbClr val="000000"/>
+                </a:solidFill>
+                <a:latin typeface="Arial Unicode MS"/>
+                <a:ea typeface="Arial Unicode MS"/>
+                <a:cs typeface="Arial Unicode MS"/>
+              </a:rPr>
+              <a:t>右邊那幾台汽車，二十七到二十九公尺，四台框都是綠色，每台兩到三個雷達點，只有一台是一個點。答案是 </a:t>
+            </a:r>
+            <a:r>
+              <a:rPr sz="1350" b="1" lang="zh-TW" dirty="0">
+                <a:solidFill>
+                  <a:srgbClr val="000000"/>
+                </a:solidFill>
+                <a:latin typeface="Arial Unicode MS"/>
+                <a:ea typeface="Arial Unicode MS"/>
+                <a:cs typeface="Arial Unicode MS"/>
+              </a:rPr>
+              <a:t>4 台</a:t>
+            </a:r>
+            <a:r>
+              <a:rPr sz="1350" lang="zh-TW" dirty="0">
+                <a:solidFill>
+                  <a:srgbClr val="000000"/>
+                </a:solidFill>
+                <a:latin typeface="Arial Unicode MS"/>
+                <a:ea typeface="Arial Unicode MS"/>
+                <a:cs typeface="Arial Unicode MS"/>
+              </a:rPr>
+              <a:t>。
 </a:t>
             </a:r>
           </a:p>
@@ -2116,11 +2215,55 @@
                 <a:spcPts val="0"/>
               </a:spcBef>
               <a:spcAft>
-                <a:spcPts val="250"/>
+                <a:spcPts val="225"/>
               </a:spcAft>
             </a:pPr>
             <a:r>
-              <a:rPr sz="1500" lang="zh-TW" dirty="0">
+              <a:rPr sz="1350" lang="zh-TW" dirty="0">
+                <a:solidFill>
+                  <a:srgbClr val="000000"/>
+                </a:solidFill>
+                <a:latin typeface="Arial Unicode MS"/>
+                <a:ea typeface="Arial Unicode MS"/>
+                <a:cs typeface="Arial Unicode MS"/>
+              </a:rPr>
+              <a:t>兩題放在一起看：</a:t>
+            </a:r>
+            <a:r>
+              <a:rPr sz="1350" b="1" lang="zh-TW" dirty="0">
+                <a:solidFill>
+                  <a:srgbClr val="000000"/>
+                </a:solidFill>
+                <a:latin typeface="Arial Unicode MS"/>
+                <a:ea typeface="Arial Unicode MS"/>
+                <a:cs typeface="Arial Unicode MS"/>
+              </a:rPr>
+              <a:t>機車比汽車近，雷達反而抓不太到。</a:t>
+            </a:r>
+            <a:r>
+              <a:rPr sz="1350" lang="zh-TW" dirty="0">
+                <a:solidFill>
+                  <a:srgbClr val="000000"/>
+                </a:solidFill>
+                <a:latin typeface="Arial Unicode MS"/>
+                <a:ea typeface="Arial Unicode MS"/>
+                <a:cs typeface="Arial Unicode MS"/>
+              </a:rPr>
+              <a:t>汽車是一大塊金屬，像一面鏡子；機車小，很多部分是塑膠，人坐在上面，電波回來很弱。
+</a:t>
+            </a:r>
+          </a:p>
+          <a:p>
+            <a:pPr algn="l">
+              <a:spcBef>
+                <a:spcPts val="0"/>
+              </a:spcBef>
+              <a:spcAft>
+                <a:spcPts val="225"/>
+              </a:spcAft>
+            </a:pPr>
+            <a:r>
+              <a:rPr sz="1350" lang="zh-TW" dirty="0">
                 <a:solidFill>
                   <a:srgbClr val="000000"/>
                 </a:solidFill>
@@ -2491,7 +2634,7 @@
                 <a:ea typeface="Arial Unicode MS"/>
                 <a:cs typeface="Arial Unicode MS"/>
               </a:rPr>
-              <a:t>。天黑了，相機看不清楚，光達的點一個都沒少。
+              <a:t>。天黑了，相機看不清楚，光達的點沒有變少。
 </a:t>
             </a:r>
           </a:p>
@@ -3205,11 +3348,11 @@
                 <a:spcPts val="0"/>
               </a:spcBef>
               <a:spcAft>
-                <a:spcPts val="183"/>
+                <a:spcPts val="167"/>
               </a:spcAft>
             </a:pPr>
             <a:r>
-              <a:rPr sz="1100" b="1" lang="zh-TW" dirty="0">
+              <a:rPr sz="1000" b="1" lang="zh-TW" dirty="0">
                 <a:solidFill>
                   <a:srgbClr val="000000"/>
                 </a:solidFill>
@@ -3220,7 +3363,7 @@
               <a:t>這一張的目的：</a:t>
             </a:r>
             <a:r>
-              <a:rPr sz="1100" lang="zh-TW" dirty="0">
+              <a:rPr sz="1000" lang="zh-TW" dirty="0">
                 <a:solidFill>
                   <a:srgbClr val="000000"/>
                 </a:solidFill>
@@ -3238,11 +3381,11 @@
                 <a:spcPts val="0"/>
               </a:spcBef>
               <a:spcAft>
-                <a:spcPts val="183"/>
+                <a:spcPts val="167"/>
               </a:spcAft>
             </a:pPr>
             <a:r>
-              <a:rPr sz="1100" lang="zh-TW" dirty="0">
+              <a:rPr sz="1000" lang="zh-TW" dirty="0">
                 <a:solidFill>
                   <a:srgbClr val="000000"/>
                 </a:solidFill>
@@ -3253,7 +3396,7 @@
               <a:t>任務五，</a:t>
             </a:r>
             <a:r>
-              <a:rPr sz="1100" b="1" lang="zh-TW" dirty="0">
+              <a:rPr sz="1000" b="1" lang="zh-TW" dirty="0">
                 <a:solidFill>
                   <a:srgbClr val="000000"/>
                 </a:solidFill>
@@ -3264,7 +3407,7 @@
               <a:t>搭檔卡</a:t>
             </a:r>
             <a:r>
-              <a:rPr sz="1100" lang="zh-TW" dirty="0">
+              <a:rPr sz="1000" lang="zh-TW" dirty="0">
                 <a:solidFill>
                   <a:srgbClr val="000000"/>
                 </a:solidFill>
@@ -3282,11 +3425,11 @@
                 <a:spcPts val="0"/>
               </a:spcBef>
               <a:spcAft>
-                <a:spcPts val="183"/>
+                <a:spcPts val="167"/>
               </a:spcAft>
             </a:pPr>
             <a:r>
-              <a:rPr sz="1100" lang="zh-TW" dirty="0">
+              <a:rPr sz="1000" lang="zh-TW" dirty="0">
                 <a:solidFill>
                   <a:srgbClr val="000000"/>
                 </a:solidFill>
@@ -3297,7 +3440,7 @@
               <a:t>先示範一下。場景按「夜間雨後」，打開相機畫面上方那排最右邊、新的開關「</a:t>
             </a:r>
             <a:r>
-              <a:rPr sz="1100" b="1" lang="zh-TW" dirty="0">
+              <a:rPr sz="1000" b="1" lang="zh-TW" dirty="0">
                 <a:solidFill>
                   <a:srgbClr val="000000"/>
                 </a:solidFill>
@@ -3308,15 +3451,15 @@
               <a:t>合起來</a:t>
             </a:r>
             <a:r>
-              <a:rPr sz="1100" lang="zh-TW" dirty="0">
-                <a:solidFill>
-                  <a:srgbClr val="000000"/>
-                </a:solidFill>
-                <a:latin typeface="Arial Unicode MS"/>
-                <a:ea typeface="Arial Unicode MS"/>
-                <a:cs typeface="Arial Unicode MS"/>
-              </a:rPr>
-              <a:t>」。每個框上面會出現一行字，像「車・12 m・遠離 18」。三段分別是：相機認出來的「車」、光達量的「12 公尺」、雷達量的「遠離，時速 18」。右邊表格也多了一欄「雷達：多快」。
+              <a:rPr sz="1000" lang="zh-TW" dirty="0">
+                <a:solidFill>
+                  <a:srgbClr val="000000"/>
+                </a:solidFill>
+                <a:latin typeface="Arial Unicode MS"/>
+                <a:ea typeface="Arial Unicode MS"/>
+                <a:cs typeface="Arial Unicode MS"/>
+              </a:rPr>
+              <a:t>」。每個框上面會出現一行字，像「車・12 m・遠離 18」。三段分別是：相機認出來的「車」、光達量的「12 公尺」、雷達量的「遠離，時速 18」，也就是那台車自己以時速 18 往遠處開。右邊表格也多了一欄「雷達：多快」。
 </a:t>
             </a:r>
           </a:p>
@@ -3326,11 +3469,11 @@
                 <a:spcPts val="0"/>
               </a:spcBef>
               <a:spcAft>
-                <a:spcPts val="183"/>
+                <a:spcPts val="167"/>
               </a:spcAft>
             </a:pPr>
             <a:r>
-              <a:rPr sz="1100" lang="zh-TW" dirty="0">
+              <a:rPr sz="1000" lang="zh-TW" dirty="0">
                 <a:solidFill>
                   <a:srgbClr val="000000"/>
                 </a:solidFill>
@@ -3348,11 +3491,11 @@
                 <a:spcPts val="0"/>
               </a:spcBef>
               <a:spcAft>
-                <a:spcPts val="183"/>
+                <a:spcPts val="167"/>
               </a:spcAft>
             </a:pPr>
             <a:r>
-              <a:rPr sz="1100" b="1" lang="zh-TW" dirty="0">
+              <a:rPr sz="1000" b="1" lang="zh-TW" dirty="0">
                 <a:solidFill>
                   <a:srgbClr val="000000"/>
                 </a:solidFill>
@@ -3363,7 +3506,7 @@
               <a:t>第 10 題。</a:t>
             </a:r>
             <a:r>
-              <a:rPr sz="1100" lang="zh-TW" dirty="0">
+              <a:rPr sz="1000" lang="zh-TW" dirty="0">
                 <a:solidFill>
                   <a:srgbClr val="000000"/>
                 </a:solidFill>
@@ -3374,26 +3517,26 @@
               <a:t>表格 12.0 m 那台車，就是畫面最左邊、只拍到一半的那一台。「雷達：多快」寫「遠離 18」。所以答案是：</a:t>
             </a:r>
             <a:r>
-              <a:rPr sz="1100" b="1" lang="zh-TW" dirty="0">
-                <a:solidFill>
-                  <a:srgbClr val="000000"/>
-                </a:solidFill>
-                <a:latin typeface="Arial Unicode MS"/>
-                <a:ea typeface="Arial Unicode MS"/>
-                <a:cs typeface="Arial Unicode MS"/>
-              </a:rPr>
-              <a:t>一台車，約 12 公尺，正以時速約 18 公里遠離。</a:t>
-            </a:r>
-            <a:r>
-              <a:rPr sz="1100" lang="zh-TW" dirty="0">
-                <a:solidFill>
-                  <a:srgbClr val="000000"/>
-                </a:solidFill>
-                <a:latin typeface="Arial Unicode MS"/>
-                <a:ea typeface="Arial Unicode MS"/>
-                <a:cs typeface="Arial Unicode MS"/>
-              </a:rPr>
-              <a:t>我拿官方標註前後兩格的位置算過，這台車真的是時速 18 左右在離開，雷達量得很準。
+              <a:rPr sz="1000" b="1" lang="zh-TW" dirty="0">
+                <a:solidFill>
+                  <a:srgbClr val="000000"/>
+                </a:solidFill>
+                <a:latin typeface="Arial Unicode MS"/>
+                <a:ea typeface="Arial Unicode MS"/>
+                <a:cs typeface="Arial Unicode MS"/>
+              </a:rPr>
+              <a:t>一台車，約 12 公尺，正以時速約 18 公里往遠處開。</a:t>
+            </a:r>
+            <a:r>
+              <a:rPr sz="1000" lang="zh-TW" dirty="0">
+                <a:solidFill>
+                  <a:srgbClr val="000000"/>
+                </a:solidFill>
+                <a:latin typeface="Arial Unicode MS"/>
+                <a:ea typeface="Arial Unicode MS"/>
+                <a:cs typeface="Arial Unicode MS"/>
+              </a:rPr>
+              <a:t>我拿官方標註前後兩格的位置算過，這台車真的是時速 18 左右在開，雷達量得很準。
 </a:t>
             </a:r>
           </a:p>
@@ -3403,118 +3546,41 @@
                 <a:spcPts val="0"/>
               </a:spcBef>
               <a:spcAft>
-                <a:spcPts val="183"/>
+                <a:spcPts val="167"/>
               </a:spcAft>
             </a:pPr>
             <a:r>
-              <a:rPr sz="1100" b="1" lang="zh-TW" dirty="0">
-                <a:solidFill>
-                  <a:srgbClr val="000000"/>
-                </a:solidFill>
-                <a:latin typeface="Arial Unicode MS"/>
-                <a:ea typeface="Arial Unicode MS"/>
-                <a:cs typeface="Arial Unicode MS"/>
-              </a:rPr>
-              <a:t>第 11 題。</a:t>
-            </a:r>
-            <a:r>
-              <a:rPr sz="1100" lang="zh-TW" dirty="0">
-                <a:solidFill>
-                  <a:srgbClr val="000000"/>
-                </a:solidFill>
-                <a:latin typeface="Arial Unicode MS"/>
-                <a:ea typeface="Arial Unicode MS"/>
-                <a:cs typeface="Arial Unicode MS"/>
-              </a:rPr>
-              <a:t>「一台車」最靠</a:t>
-            </a:r>
-            <a:r>
-              <a:rPr sz="1100" b="1" lang="zh-TW" dirty="0">
-                <a:solidFill>
-                  <a:srgbClr val="000000"/>
-                </a:solidFill>
-                <a:latin typeface="Arial Unicode MS"/>
-                <a:ea typeface="Arial Unicode MS"/>
-                <a:cs typeface="Arial Unicode MS"/>
-              </a:rPr>
-              <a:t>相機</a:t>
-            </a:r>
-            <a:r>
-              <a:rPr sz="1100" lang="zh-TW" dirty="0">
-                <a:solidFill>
-                  <a:srgbClr val="000000"/>
-                </a:solidFill>
-                <a:latin typeface="Arial Unicode MS"/>
-                <a:ea typeface="Arial Unicode MS"/>
-                <a:cs typeface="Arial Unicode MS"/>
-              </a:rPr>
-              <a:t>，只有它認得出那是車；「12 公尺」最靠</a:t>
-            </a:r>
-            <a:r>
-              <a:rPr sz="1100" b="1" lang="zh-TW" dirty="0">
-                <a:solidFill>
-                  <a:srgbClr val="000000"/>
-                </a:solidFill>
-                <a:latin typeface="Arial Unicode MS"/>
-                <a:ea typeface="Arial Unicode MS"/>
-                <a:cs typeface="Arial Unicode MS"/>
-              </a:rPr>
-              <a:t>光達</a:t>
-            </a:r>
-            <a:r>
-              <a:rPr sz="1100" lang="zh-TW" dirty="0">
-                <a:solidFill>
-                  <a:srgbClr val="000000"/>
-                </a:solidFill>
-                <a:latin typeface="Arial Unicode MS"/>
-                <a:ea typeface="Arial Unicode MS"/>
-                <a:cs typeface="Arial Unicode MS"/>
-              </a:rPr>
-              <a:t>，表格的距離是用官方標註的框算的，那個框是照光達的點畫出來的；「時速 18 遠離」最靠</a:t>
-            </a:r>
-            <a:r>
-              <a:rPr sz="1100" b="1" lang="zh-TW" dirty="0">
-                <a:solidFill>
-                  <a:srgbClr val="000000"/>
-                </a:solidFill>
-                <a:latin typeface="Arial Unicode MS"/>
-                <a:ea typeface="Arial Unicode MS"/>
-                <a:cs typeface="Arial Unicode MS"/>
-              </a:rPr>
-              <a:t>雷達</a:t>
-            </a:r>
-            <a:r>
-              <a:rPr sz="1100" lang="zh-TW" dirty="0">
-                <a:solidFill>
-                  <a:srgbClr val="000000"/>
-                </a:solidFill>
-                <a:latin typeface="Arial Unicode MS"/>
-                <a:ea typeface="Arial Unicode MS"/>
-                <a:cs typeface="Arial Unicode MS"/>
-              </a:rPr>
-              <a:t>，它用都卜勒直接量速度。答案是「</a:t>
-            </a:r>
-            <a:r>
-              <a:rPr sz="1100" b="1" lang="zh-TW" dirty="0">
-                <a:solidFill>
-                  <a:srgbClr val="000000"/>
-                </a:solidFill>
-                <a:latin typeface="Arial Unicode MS"/>
-                <a:ea typeface="Arial Unicode MS"/>
-                <a:cs typeface="Arial Unicode MS"/>
-              </a:rPr>
-              <a:t>相機／光達／雷達</a:t>
-            </a:r>
-            <a:r>
-              <a:rPr sz="1100" lang="zh-TW" dirty="0">
-                <a:solidFill>
-                  <a:srgbClr val="000000"/>
-                </a:solidFill>
-                <a:latin typeface="Arial Unicode MS"/>
-                <a:ea typeface="Arial Unicode MS"/>
-                <a:cs typeface="Arial Unicode MS"/>
-              </a:rPr>
-              <a:t>」。
+              <a:rPr sz="1000" lang="zh-TW" dirty="0">
+                <a:solidFill>
+                  <a:srgbClr val="000000"/>
+                </a:solidFill>
+                <a:latin typeface="Arial Unicode MS"/>
+                <a:ea typeface="Arial Unicode MS"/>
+                <a:cs typeface="Arial Unicode MS"/>
+              </a:rPr>
+              <a:t>要提醒一件事：這個 18 是那台車</a:t>
+            </a:r>
+            <a:r>
+              <a:rPr sz="1000" b="1" lang="zh-TW" dirty="0">
+                <a:solidFill>
+                  <a:srgbClr val="000000"/>
+                </a:solidFill>
+                <a:latin typeface="Arial Unicode MS"/>
+                <a:ea typeface="Arial Unicode MS"/>
+                <a:cs typeface="Arial Unicode MS"/>
+              </a:rPr>
+              <a:t>自己</a:t>
+            </a:r>
+            <a:r>
+              <a:rPr sz="1000" lang="zh-TW" dirty="0">
+                <a:solidFill>
+                  <a:srgbClr val="000000"/>
+                </a:solidFill>
+                <a:latin typeface="Arial Unicode MS"/>
+                <a:ea typeface="Arial Unicode MS"/>
+                <a:cs typeface="Arial Unicode MS"/>
+              </a:rPr>
+              <a:t>的速度。我們的車這時候也以時速大約 9 往前開，所以兩台車之間的距離，只以時速 9 公里左右慢慢拉開。雷達原本量到的是兩台車之間的相對速度，扣掉自己的車速，才得到那台車自己的速度，就是第一節講的那個減法。
 </a:t>
             </a:r>
           </a:p>
@@ -3524,88 +3590,110 @@
                 <a:spcPts val="0"/>
               </a:spcBef>
               <a:spcAft>
-                <a:spcPts val="183"/>
+                <a:spcPts val="167"/>
               </a:spcAft>
             </a:pPr>
             <a:r>
-              <a:rPr sz="1100" b="1" lang="zh-TW" dirty="0">
-                <a:solidFill>
-                  <a:srgbClr val="000000"/>
-                </a:solidFill>
-                <a:latin typeface="Arial Unicode MS"/>
-                <a:ea typeface="Arial Unicode MS"/>
-                <a:cs typeface="Arial Unicode MS"/>
-              </a:rPr>
-              <a:t>第 12 題。</a:t>
-            </a:r>
-            <a:r>
-              <a:rPr sz="1100" lang="zh-TW" dirty="0">
-                <a:solidFill>
-                  <a:srgbClr val="000000"/>
-                </a:solidFill>
-                <a:latin typeface="Arial Unicode MS"/>
-                <a:ea typeface="Arial Unicode MS"/>
-                <a:cs typeface="Arial Unicode MS"/>
-              </a:rPr>
-              <a:t>這題最重要。場景換「夜間」，那台黑色轎車，任務三看過，正在開過路口。可是「雷達：多快」寫 </a:t>
-            </a:r>
-            <a:r>
-              <a:rPr sz="1100" b="1" lang="zh-TW" dirty="0">
-                <a:solidFill>
-                  <a:srgbClr val="000000"/>
-                </a:solidFill>
-                <a:latin typeface="Arial Unicode MS"/>
-                <a:ea typeface="Arial Unicode MS"/>
-                <a:cs typeface="Arial Unicode MS"/>
-              </a:rPr>
-              <a:t>≈0</a:t>
-            </a:r>
-            <a:r>
-              <a:rPr sz="1100" lang="zh-TW" dirty="0">
-                <a:solidFill>
-                  <a:srgbClr val="000000"/>
-                </a:solidFill>
-                <a:latin typeface="Arial Unicode MS"/>
-                <a:ea typeface="Arial Unicode MS"/>
-                <a:cs typeface="Arial Unicode MS"/>
-              </a:rPr>
-              <a:t>。雷達壞了嗎？沒有。我用官方標註算過，這台車實際上大約時速二十二，可是它是</a:t>
-            </a:r>
-            <a:r>
-              <a:rPr sz="1100" b="1" lang="zh-TW" dirty="0">
-                <a:solidFill>
-                  <a:srgbClr val="000000"/>
-                </a:solidFill>
-                <a:latin typeface="Arial Unicode MS"/>
-                <a:ea typeface="Arial Unicode MS"/>
-                <a:cs typeface="Arial Unicode MS"/>
-              </a:rPr>
-              <a:t>橫著開</a:t>
-            </a:r>
-            <a:r>
-              <a:rPr sz="1100" lang="zh-TW" dirty="0">
-                <a:solidFill>
-                  <a:srgbClr val="000000"/>
-                </a:solidFill>
-                <a:latin typeface="Arial Unicode MS"/>
-                <a:ea typeface="Arial Unicode MS"/>
-                <a:cs typeface="Arial Unicode MS"/>
-              </a:rPr>
-              <a:t>的，朝我們靠近的那一段速度，只有時速五左右。雷達用都卜勒量速度，只量得到「朝我來、離我去」的那一段。就像站在路邊看一台車從左邊開到右邊，它沒有變近、也沒有變遠。答案是「</a:t>
-            </a:r>
-            <a:r>
-              <a:rPr sz="1100" b="1" lang="zh-TW" dirty="0">
-                <a:solidFill>
-                  <a:srgbClr val="000000"/>
-                </a:solidFill>
-                <a:latin typeface="Arial Unicode MS"/>
-                <a:ea typeface="Arial Unicode MS"/>
-                <a:cs typeface="Arial Unicode MS"/>
-              </a:rPr>
-              <a:t>它是橫著開，雷達只量得到朝自己靠近或遠離的那一段</a:t>
-            </a:r>
-            <a:r>
-              <a:rPr sz="1100" lang="zh-TW" dirty="0">
+              <a:rPr sz="1000" b="1" lang="zh-TW" dirty="0">
+                <a:solidFill>
+                  <a:srgbClr val="000000"/>
+                </a:solidFill>
+                <a:latin typeface="Arial Unicode MS"/>
+                <a:ea typeface="Arial Unicode MS"/>
+                <a:cs typeface="Arial Unicode MS"/>
+              </a:rPr>
+              <a:t>第 11 題。</a:t>
+            </a:r>
+            <a:r>
+              <a:rPr sz="1000" lang="zh-TW" dirty="0">
+                <a:solidFill>
+                  <a:srgbClr val="000000"/>
+                </a:solidFill>
+                <a:latin typeface="Arial Unicode MS"/>
+                <a:ea typeface="Arial Unicode MS"/>
+                <a:cs typeface="Arial Unicode MS"/>
+              </a:rPr>
+              <a:t>「一台車」最靠</a:t>
+            </a:r>
+            <a:r>
+              <a:rPr sz="1000" b="1" lang="zh-TW" dirty="0">
+                <a:solidFill>
+                  <a:srgbClr val="000000"/>
+                </a:solidFill>
+                <a:latin typeface="Arial Unicode MS"/>
+                <a:ea typeface="Arial Unicode MS"/>
+                <a:cs typeface="Arial Unicode MS"/>
+              </a:rPr>
+              <a:t>相機</a:t>
+            </a:r>
+            <a:r>
+              <a:rPr sz="1000" lang="zh-TW" dirty="0">
+                <a:solidFill>
+                  <a:srgbClr val="000000"/>
+                </a:solidFill>
+                <a:latin typeface="Arial Unicode MS"/>
+                <a:ea typeface="Arial Unicode MS"/>
+                <a:cs typeface="Arial Unicode MS"/>
+              </a:rPr>
+              <a:t>，只有它認得出那是車；「12 公尺」最靠</a:t>
+            </a:r>
+            <a:r>
+              <a:rPr sz="1000" b="1" lang="zh-TW" dirty="0">
+                <a:solidFill>
+                  <a:srgbClr val="000000"/>
+                </a:solidFill>
+                <a:latin typeface="Arial Unicode MS"/>
+                <a:ea typeface="Arial Unicode MS"/>
+                <a:cs typeface="Arial Unicode MS"/>
+              </a:rPr>
+              <a:t>光達</a:t>
+            </a:r>
+            <a:r>
+              <a:rPr sz="1000" lang="zh-TW" dirty="0">
+                <a:solidFill>
+                  <a:srgbClr val="000000"/>
+                </a:solidFill>
+                <a:latin typeface="Arial Unicode MS"/>
+                <a:ea typeface="Arial Unicode MS"/>
+                <a:cs typeface="Arial Unicode MS"/>
+              </a:rPr>
+              <a:t>，表格的距離是用官方標註的框算的，那個框是照光達的點畫出來的；「時速 18 往遠處開」最靠</a:t>
+            </a:r>
+            <a:r>
+              <a:rPr sz="1000" b="1" lang="zh-TW" dirty="0">
+                <a:solidFill>
+                  <a:srgbClr val="000000"/>
+                </a:solidFill>
+                <a:latin typeface="Arial Unicode MS"/>
+                <a:ea typeface="Arial Unicode MS"/>
+                <a:cs typeface="Arial Unicode MS"/>
+              </a:rPr>
+              <a:t>雷達</a:t>
+            </a:r>
+            <a:r>
+              <a:rPr sz="1000" lang="zh-TW" dirty="0">
+                <a:solidFill>
+                  <a:srgbClr val="000000"/>
+                </a:solidFill>
+                <a:latin typeface="Arial Unicode MS"/>
+                <a:ea typeface="Arial Unicode MS"/>
+                <a:cs typeface="Arial Unicode MS"/>
+              </a:rPr>
+              <a:t>，它用都卜勒直接量速度。答案是「</a:t>
+            </a:r>
+            <a:r>
+              <a:rPr sz="1000" b="1" lang="zh-TW" dirty="0">
+                <a:solidFill>
+                  <a:srgbClr val="000000"/>
+                </a:solidFill>
+                <a:latin typeface="Arial Unicode MS"/>
+                <a:ea typeface="Arial Unicode MS"/>
+                <a:cs typeface="Arial Unicode MS"/>
+              </a:rPr>
+              <a:t>相機／光達／雷達</a:t>
+            </a:r>
+            <a:r>
+              <a:rPr sz="1000" lang="zh-TW" dirty="0">
                 <a:solidFill>
                   <a:srgbClr val="000000"/>
                 </a:solidFill>
@@ -3623,19 +3711,96 @@
                 <a:spcPts val="0"/>
               </a:spcBef>
               <a:spcAft>
-                <a:spcPts val="183"/>
+                <a:spcPts val="167"/>
               </a:spcAft>
             </a:pPr>
             <a:r>
-              <a:rPr sz="1100" lang="zh-TW" dirty="0">
-                <a:solidFill>
-                  <a:srgbClr val="000000"/>
-                </a:solidFill>
-                <a:latin typeface="Arial Unicode MS"/>
-                <a:ea typeface="Arial Unicode MS"/>
-                <a:cs typeface="Arial Unicode MS"/>
-              </a:rPr>
-              <a:t>所以雷達量的速度，也有盲點。橫著開過去的車，要靠什麼知道它多快？跟下一題一樣。
+              <a:rPr sz="1000" b="1" lang="zh-TW" dirty="0">
+                <a:solidFill>
+                  <a:srgbClr val="000000"/>
+                </a:solidFill>
+                <a:latin typeface="Arial Unicode MS"/>
+                <a:ea typeface="Arial Unicode MS"/>
+                <a:cs typeface="Arial Unicode MS"/>
+              </a:rPr>
+              <a:t>第 12 題。</a:t>
+            </a:r>
+            <a:r>
+              <a:rPr sz="1000" lang="zh-TW" dirty="0">
+                <a:solidFill>
+                  <a:srgbClr val="000000"/>
+                </a:solidFill>
+                <a:latin typeface="Arial Unicode MS"/>
+                <a:ea typeface="Arial Unicode MS"/>
+                <a:cs typeface="Arial Unicode MS"/>
+              </a:rPr>
+              <a:t>這題最重要。場景換「夜間」，那台黑色轎車，任務三看過，正在開過路口。可是「雷達：多快」寫 </a:t>
+            </a:r>
+            <a:r>
+              <a:rPr sz="1000" b="1" lang="zh-TW" dirty="0">
+                <a:solidFill>
+                  <a:srgbClr val="000000"/>
+                </a:solidFill>
+                <a:latin typeface="Arial Unicode MS"/>
+                <a:ea typeface="Arial Unicode MS"/>
+                <a:cs typeface="Arial Unicode MS"/>
+              </a:rPr>
+              <a:t>≈0</a:t>
+            </a:r>
+            <a:r>
+              <a:rPr sz="1000" lang="zh-TW" dirty="0">
+                <a:solidFill>
+                  <a:srgbClr val="000000"/>
+                </a:solidFill>
+                <a:latin typeface="Arial Unicode MS"/>
+                <a:ea typeface="Arial Unicode MS"/>
+                <a:cs typeface="Arial Unicode MS"/>
+              </a:rPr>
+              <a:t>。雷達壞了嗎？沒有。我用官方標註算過，這台車實際上大約時速二十二，可是它是</a:t>
+            </a:r>
+            <a:r>
+              <a:rPr sz="1000" b="1" lang="zh-TW" dirty="0">
+                <a:solidFill>
+                  <a:srgbClr val="000000"/>
+                </a:solidFill>
+                <a:latin typeface="Arial Unicode MS"/>
+                <a:ea typeface="Arial Unicode MS"/>
+                <a:cs typeface="Arial Unicode MS"/>
+              </a:rPr>
+              <a:t>橫著開</a:t>
+            </a:r>
+            <a:r>
+              <a:rPr sz="1000" lang="zh-TW" dirty="0">
+                <a:solidFill>
+                  <a:srgbClr val="000000"/>
+                </a:solidFill>
+                <a:latin typeface="Arial Unicode MS"/>
+                <a:ea typeface="Arial Unicode MS"/>
+                <a:cs typeface="Arial Unicode MS"/>
+              </a:rPr>
+              <a:t>的，朝我們靠近的那一段速度，只有時速五左右。雷達用都卜勒量速度，只量得到「朝我來、離我去」的那一段。就像站在路邊看一台車從左邊開到右邊，它沒有變近、也沒有變遠。答案是「</a:t>
+            </a:r>
+            <a:r>
+              <a:rPr sz="1000" b="1" lang="zh-TW" dirty="0">
+                <a:solidFill>
+                  <a:srgbClr val="000000"/>
+                </a:solidFill>
+                <a:latin typeface="Arial Unicode MS"/>
+                <a:ea typeface="Arial Unicode MS"/>
+                <a:cs typeface="Arial Unicode MS"/>
+              </a:rPr>
+              <a:t>它是橫著開，雷達只量得到朝自己靠近或遠離的那一段</a:t>
+            </a:r>
+            <a:r>
+              <a:rPr sz="1000" lang="zh-TW" dirty="0">
+                <a:solidFill>
+                  <a:srgbClr val="000000"/>
+                </a:solidFill>
+                <a:latin typeface="Arial Unicode MS"/>
+                <a:ea typeface="Arial Unicode MS"/>
+                <a:cs typeface="Arial Unicode MS"/>
+              </a:rPr>
+              <a:t>」。
 </a:t>
             </a:r>
           </a:p>
@@ -3645,52 +3810,19 @@
                 <a:spcPts val="0"/>
               </a:spcBef>
               <a:spcAft>
-                <a:spcPts val="183"/>
+                <a:spcPts val="167"/>
               </a:spcAft>
             </a:pPr>
             <a:r>
-              <a:rPr sz="1100" b="1" lang="zh-TW" dirty="0">
-                <a:solidFill>
-                  <a:srgbClr val="000000"/>
-                </a:solidFill>
-                <a:latin typeface="Arial Unicode MS"/>
-                <a:ea typeface="Arial Unicode MS"/>
-                <a:cs typeface="Arial Unicode MS"/>
-              </a:rPr>
-              <a:t>第 13 題。</a:t>
-            </a:r>
-            <a:r>
-              <a:rPr sz="1100" lang="zh-TW" dirty="0">
-                <a:solidFill>
-                  <a:srgbClr val="000000"/>
-                </a:solidFill>
-                <a:latin typeface="Arial Unicode MS"/>
-                <a:ea typeface="Arial Unicode MS"/>
-                <a:cs typeface="Arial Unicode MS"/>
-              </a:rPr>
-              <a:t>斑馬線上 10.2 m 的行人，雷達一個點都沒有，速度是「—」。這一塊要怎麼補？速度就是「位置變了多少，除以過了多久」。光達每秒轉二十圈，把它連續幾格的位置記下來，一除就知道他走多快。答案是「</a:t>
-            </a:r>
-            <a:r>
-              <a:rPr sz="1100" b="1" lang="zh-TW" dirty="0">
-                <a:solidFill>
-                  <a:srgbClr val="000000"/>
-                </a:solidFill>
-                <a:latin typeface="Arial Unicode MS"/>
-                <a:ea typeface="Arial Unicode MS"/>
-                <a:cs typeface="Arial Unicode MS"/>
-              </a:rPr>
-              <a:t>用光達（或相機）連續幾格的位置變化，算出他走多快</a:t>
-            </a:r>
-            <a:r>
-              <a:rPr sz="1100" lang="zh-TW" dirty="0">
-                <a:solidFill>
-                  <a:srgbClr val="000000"/>
-                </a:solidFill>
-                <a:latin typeface="Arial Unicode MS"/>
-                <a:ea typeface="Arial Unicode MS"/>
-                <a:cs typeface="Arial Unicode MS"/>
-              </a:rPr>
-              <a:t>」。這就是第二節講的追蹤。
+              <a:rPr sz="1000" lang="zh-TW" dirty="0">
+                <a:solidFill>
+                  <a:srgbClr val="000000"/>
+                </a:solidFill>
+                <a:latin typeface="Arial Unicode MS"/>
+                <a:ea typeface="Arial Unicode MS"/>
+                <a:cs typeface="Arial Unicode MS"/>
+              </a:rPr>
+              <a:t>所以雷達量的速度，也有盲點。橫著開過去的車，要靠什麼知道它多快？跟下一題一樣。
 </a:t>
             </a:r>
           </a:p>
@@ -3700,11 +3832,66 @@
                 <a:spcPts val="0"/>
               </a:spcBef>
               <a:spcAft>
-                <a:spcPts val="183"/>
+                <a:spcPts val="167"/>
               </a:spcAft>
             </a:pPr>
             <a:r>
-              <a:rPr sz="1100" lang="zh-TW" dirty="0">
+              <a:rPr sz="1000" b="1" lang="zh-TW" dirty="0">
+                <a:solidFill>
+                  <a:srgbClr val="000000"/>
+                </a:solidFill>
+                <a:latin typeface="Arial Unicode MS"/>
+                <a:ea typeface="Arial Unicode MS"/>
+                <a:cs typeface="Arial Unicode MS"/>
+              </a:rPr>
+              <a:t>第 13 題。</a:t>
+            </a:r>
+            <a:r>
+              <a:rPr sz="1000" lang="zh-TW" dirty="0">
+                <a:solidFill>
+                  <a:srgbClr val="000000"/>
+                </a:solidFill>
+                <a:latin typeface="Arial Unicode MS"/>
+                <a:ea typeface="Arial Unicode MS"/>
+                <a:cs typeface="Arial Unicode MS"/>
+              </a:rPr>
+              <a:t>斑馬線上 10.2 m 的行人，雷達一個點都沒有，速度是「—」。這一塊要怎麼補？速度就是「位置變了多少，除以過了多久」。光達每秒轉二十圈，把它連續幾格的位置記下來，一除就知道他走多快。答案是「</a:t>
+            </a:r>
+            <a:r>
+              <a:rPr sz="1000" b="1" lang="zh-TW" dirty="0">
+                <a:solidFill>
+                  <a:srgbClr val="000000"/>
+                </a:solidFill>
+                <a:latin typeface="Arial Unicode MS"/>
+                <a:ea typeface="Arial Unicode MS"/>
+                <a:cs typeface="Arial Unicode MS"/>
+              </a:rPr>
+              <a:t>用光達（或相機）連續幾格的位置變化，算出他走多快</a:t>
+            </a:r>
+            <a:r>
+              <a:rPr sz="1000" lang="zh-TW" dirty="0">
+                <a:solidFill>
+                  <a:srgbClr val="000000"/>
+                </a:solidFill>
+                <a:latin typeface="Arial Unicode MS"/>
+                <a:ea typeface="Arial Unicode MS"/>
+                <a:cs typeface="Arial Unicode MS"/>
+              </a:rPr>
+              <a:t>」。這就是第二節講的追蹤。
+</a:t>
+            </a:r>
+          </a:p>
+          <a:p>
+            <a:pPr algn="l">
+              <a:spcBef>
+                <a:spcPts val="0"/>
+              </a:spcBef>
+              <a:spcAft>
+                <a:spcPts val="167"/>
+              </a:spcAft>
+            </a:pPr>
+            <a:r>
+              <a:rPr sz="1000" lang="zh-TW" dirty="0">
                 <a:solidFill>
                   <a:srgbClr val="000000"/>
                 </a:solidFill>
@@ -3715,7 +3902,7 @@
               <a:t>四題做完，各位會發現：三種感測器各給一塊，</a:t>
             </a:r>
             <a:r>
-              <a:rPr sz="1100" b="1" lang="zh-TW" dirty="0">
+              <a:rPr sz="1000" b="1" lang="zh-TW" dirty="0">
                 <a:solidFill>
                   <a:srgbClr val="000000"/>
                 </a:solidFill>
@@ -3726,7 +3913,7 @@
               <a:t>少了哪一塊，就要找另一個來補</a:t>
             </a:r>
             <a:r>
-              <a:rPr sz="1100" lang="zh-TW" dirty="0">
+              <a:rPr sz="1000" lang="zh-TW" dirty="0">
                 <a:solidFill>
                   <a:srgbClr val="000000"/>
                 </a:solidFill>
@@ -3843,11 +4030,11 @@
                 <a:spcPts val="0"/>
               </a:spcBef>
               <a:spcAft>
-                <a:spcPts val="192"/>
+                <a:spcPts val="175"/>
               </a:spcAft>
             </a:pPr>
             <a:r>
-              <a:rPr sz="1150" b="1" lang="zh-TW" dirty="0">
+              <a:rPr sz="1050" b="1" lang="zh-TW" dirty="0">
                 <a:solidFill>
                   <a:srgbClr val="000000"/>
                 </a:solidFill>
@@ -3858,7 +4045,7 @@
               <a:t>這一張的目的：</a:t>
             </a:r>
             <a:r>
-              <a:rPr sz="1150" lang="zh-TW" dirty="0">
+              <a:rPr sz="1050" lang="zh-TW" dirty="0">
                 <a:solidFill>
                   <a:srgbClr val="000000"/>
                 </a:solidFill>
@@ -3876,11 +4063,11 @@
                 <a:spcPts val="0"/>
               </a:spcBef>
               <a:spcAft>
-                <a:spcPts val="192"/>
+                <a:spcPts val="175"/>
               </a:spcAft>
             </a:pPr>
             <a:r>
-              <a:rPr sz="1150" lang="zh-TW" dirty="0">
+              <a:rPr sz="1050" lang="zh-TW" dirty="0">
                 <a:solidFill>
                   <a:srgbClr val="000000"/>
                 </a:solidFill>
@@ -3891,7 +4078,7 @@
               <a:t>任務六。第三週第一節有一張表：</a:t>
             </a:r>
             <a:r>
-              <a:rPr sz="1150" b="1" lang="zh-TW" dirty="0">
+              <a:rPr sz="1050" b="1" lang="zh-TW" dirty="0">
                 <a:solidFill>
                   <a:srgbClr val="000000"/>
                 </a:solidFill>
@@ -3902,7 +4089,7 @@
               <a:t>每一種感測器的弱點，由哪一種來補。</a:t>
             </a:r>
             <a:r>
-              <a:rPr sz="1150" lang="zh-TW" dirty="0">
+              <a:rPr sz="1050" lang="zh-TW" dirty="0">
                 <a:solidFill>
                   <a:srgbClr val="000000"/>
                 </a:solidFill>
@@ -3920,11 +4107,11 @@
                 <a:spcPts val="0"/>
               </a:spcBef>
               <a:spcAft>
-                <a:spcPts val="192"/>
+                <a:spcPts val="175"/>
               </a:spcAft>
             </a:pPr>
             <a:r>
-              <a:rPr sz="1150" lang="zh-TW" dirty="0">
+              <a:rPr sz="1050" lang="zh-TW" dirty="0">
                 <a:solidFill>
                   <a:srgbClr val="000000"/>
                 </a:solidFill>
@@ -3942,11 +4129,11 @@
                 <a:spcPts val="0"/>
               </a:spcBef>
               <a:spcAft>
-                <a:spcPts val="192"/>
+                <a:spcPts val="175"/>
               </a:spcAft>
             </a:pPr>
             <a:r>
-              <a:rPr sz="1150" lang="zh-TW" dirty="0">
+              <a:rPr sz="1050" lang="zh-TW" dirty="0">
                 <a:solidFill>
                   <a:srgbClr val="000000"/>
                 </a:solidFill>
@@ -3964,11 +4151,11 @@
                 <a:spcPts val="0"/>
               </a:spcBef>
               <a:spcAft>
-                <a:spcPts val="192"/>
+                <a:spcPts val="175"/>
               </a:spcAft>
             </a:pPr>
             <a:r>
-              <a:rPr sz="1150" b="1" lang="zh-TW" dirty="0">
+              <a:rPr sz="1050" b="1" lang="zh-TW" dirty="0">
                 <a:solidFill>
                   <a:srgbClr val="000000"/>
                 </a:solidFill>
@@ -3979,7 +4166,7 @@
               <a:t>第一列，不知道那是什麼。</a:t>
             </a:r>
             <a:r>
-              <a:rPr sz="1150" lang="zh-TW" dirty="0">
+              <a:rPr sz="1050" lang="zh-TW" dirty="0">
                 <a:solidFill>
                   <a:srgbClr val="000000"/>
                 </a:solidFill>
@@ -3990,7 +4177,7 @@
               <a:t>光達、雷達只知道有一團東西，認得出是人還是垃圾桶的，是</a:t>
             </a:r>
             <a:r>
-              <a:rPr sz="1150" b="1" lang="zh-TW" dirty="0">
+              <a:rPr sz="1050" b="1" lang="zh-TW" dirty="0">
                 <a:solidFill>
                   <a:srgbClr val="000000"/>
                 </a:solidFill>
@@ -4001,7 +4188,7 @@
               <a:t>相機</a:t>
             </a:r>
             <a:r>
-              <a:rPr sz="1150" lang="zh-TW" dirty="0">
+              <a:rPr sz="1050" lang="zh-TW" dirty="0">
                 <a:solidFill>
                   <a:srgbClr val="000000"/>
                 </a:solidFill>
@@ -4019,11 +4206,11 @@
                 <a:spcPts val="0"/>
               </a:spcBef>
               <a:spcAft>
-                <a:spcPts val="192"/>
+                <a:spcPts val="175"/>
               </a:spcAft>
             </a:pPr>
             <a:r>
-              <a:rPr sz="1150" b="1" lang="zh-TW" dirty="0">
+              <a:rPr sz="1050" b="1" lang="zh-TW" dirty="0">
                 <a:solidFill>
                   <a:srgbClr val="000000"/>
                 </a:solidFill>
@@ -4034,7 +4221,7 @@
               <a:t>第二列，讀不出紅綠燈的顏色。</a:t>
             </a:r>
             <a:r>
-              <a:rPr sz="1150" lang="zh-TW" dirty="0">
+              <a:rPr sz="1050" lang="zh-TW" dirty="0">
                 <a:solidFill>
                   <a:srgbClr val="000000"/>
                 </a:solidFill>
@@ -4045,7 +4232,7 @@
               <a:t>只有</a:t>
             </a:r>
             <a:r>
-              <a:rPr sz="1150" b="1" lang="zh-TW" dirty="0">
+              <a:rPr sz="1050" b="1" lang="zh-TW" dirty="0">
                 <a:solidFill>
                   <a:srgbClr val="000000"/>
                 </a:solidFill>
@@ -4056,7 +4243,7 @@
               <a:t>相機</a:t>
             </a:r>
             <a:r>
-              <a:rPr sz="1150" lang="zh-TW" dirty="0">
+              <a:rPr sz="1050" lang="zh-TW" dirty="0">
                 <a:solidFill>
                   <a:srgbClr val="000000"/>
                 </a:solidFill>
@@ -4074,11 +4261,11 @@
                 <a:spcPts val="0"/>
               </a:spcBef>
               <a:spcAft>
-                <a:spcPts val="192"/>
+                <a:spcPts val="175"/>
               </a:spcAft>
             </a:pPr>
             <a:r>
-              <a:rPr sz="1150" b="1" lang="zh-TW" dirty="0">
+              <a:rPr sz="1050" b="1" lang="zh-TW" dirty="0">
                 <a:solidFill>
                   <a:srgbClr val="000000"/>
                 </a:solidFill>
@@ -4089,7 +4276,7 @@
               <a:t>第三列，不知道接近得多快。</a:t>
             </a:r>
             <a:r>
-              <a:rPr sz="1150" b="1" lang="zh-TW" dirty="0">
+              <a:rPr sz="1050" b="1" lang="zh-TW" dirty="0">
                 <a:solidFill>
                   <a:srgbClr val="000000"/>
                 </a:solidFill>
@@ -4100,7 +4287,7 @@
               <a:t>雷達</a:t>
             </a:r>
             <a:r>
-              <a:rPr sz="1150" lang="zh-TW" dirty="0">
+              <a:rPr sz="1050" lang="zh-TW" dirty="0">
                 <a:solidFill>
                   <a:srgbClr val="000000"/>
                 </a:solidFill>
@@ -4118,11 +4305,11 @@
                 <a:spcPts val="0"/>
               </a:spcBef>
               <a:spcAft>
-                <a:spcPts val="192"/>
+                <a:spcPts val="175"/>
               </a:spcAft>
             </a:pPr>
             <a:r>
-              <a:rPr sz="1150" b="1" lang="zh-TW" dirty="0">
+              <a:rPr sz="1050" b="1" lang="zh-TW" dirty="0">
                 <a:solidFill>
                   <a:srgbClr val="000000"/>
                 </a:solidFill>
@@ -4133,7 +4320,7 @@
               <a:t>第四列，保險桿前面的近距離盲區。</a:t>
             </a:r>
             <a:r>
-              <a:rPr sz="1150" b="1" lang="zh-TW" dirty="0">
+              <a:rPr sz="1050" b="1" lang="zh-TW" dirty="0">
                 <a:solidFill>
                   <a:srgbClr val="000000"/>
                 </a:solidFill>
@@ -4144,7 +4331,7 @@
               <a:t>超音波</a:t>
             </a:r>
             <a:r>
-              <a:rPr sz="1150" lang="zh-TW" dirty="0">
+              <a:rPr sz="1050" lang="zh-TW" dirty="0">
                 <a:solidFill>
                   <a:srgbClr val="000000"/>
                 </a:solidFill>
@@ -4162,11 +4349,11 @@
                 <a:spcPts val="0"/>
               </a:spcBef>
               <a:spcAft>
-                <a:spcPts val="192"/>
+                <a:spcPts val="175"/>
               </a:spcAft>
             </a:pPr>
             <a:r>
-              <a:rPr sz="1150" b="1" lang="zh-TW" dirty="0">
+              <a:rPr sz="1050" b="1" lang="zh-TW" dirty="0">
                 <a:solidFill>
                   <a:srgbClr val="000000"/>
                 </a:solidFill>
@@ -4177,7 +4364,7 @@
               <a:t>第五列，天黑，相機看不清楚。</a:t>
             </a:r>
             <a:r>
-              <a:rPr sz="1150" b="1" lang="zh-TW" dirty="0">
+              <a:rPr sz="1050" b="1" lang="zh-TW" dirty="0">
                 <a:solidFill>
                   <a:srgbClr val="000000"/>
                 </a:solidFill>
@@ -4188,15 +4375,15 @@
               <a:t>光達或雷達</a:t>
             </a:r>
             <a:r>
-              <a:rPr sz="1150" lang="zh-TW" dirty="0">
-                <a:solidFill>
-                  <a:srgbClr val="000000"/>
-                </a:solidFill>
-                <a:latin typeface="Arial Unicode MS"/>
-                <a:ea typeface="Arial Unicode MS"/>
-                <a:cs typeface="Arial Unicode MS"/>
-              </a:rPr>
-              <a:t>。任務三剛剛看到：晚上光達的點一個都沒少，那台黑色轎車雷達也抓到了。
+              <a:rPr sz="1050" lang="zh-TW" dirty="0">
+                <a:solidFill>
+                  <a:srgbClr val="000000"/>
+                </a:solidFill>
+                <a:latin typeface="Arial Unicode MS"/>
+                <a:ea typeface="Arial Unicode MS"/>
+                <a:cs typeface="Arial Unicode MS"/>
+              </a:rPr>
+              <a:t>。任務三剛剛看到：晚上光達的點沒有變少，那台黑色轎車雷達也抓到了。
 </a:t>
             </a:r>
           </a:p>
@@ -4206,11 +4393,11 @@
                 <a:spcPts val="0"/>
               </a:spcBef>
               <a:spcAft>
-                <a:spcPts val="192"/>
+                <a:spcPts val="175"/>
               </a:spcAft>
             </a:pPr>
             <a:r>
-              <a:rPr sz="1150" b="1" lang="zh-TW" dirty="0">
+              <a:rPr sz="1050" b="1" lang="zh-TW" dirty="0">
                 <a:solidFill>
                   <a:srgbClr val="000000"/>
                 </a:solidFill>
@@ -4221,7 +4408,7 @@
               <a:t>第六列，不知道自己在哪裡。</a:t>
             </a:r>
             <a:r>
-              <a:rPr sz="1150" b="1" lang="zh-TW" dirty="0">
+              <a:rPr sz="1050" b="1" lang="zh-TW" dirty="0">
                 <a:solidFill>
                   <a:srgbClr val="000000"/>
                 </a:solidFill>
@@ -4232,7 +4419,7 @@
               <a:t>衛星定位加 IMU 加地圖</a:t>
             </a:r>
             <a:r>
-              <a:rPr sz="1150" lang="zh-TW" dirty="0">
+              <a:rPr sz="1050" lang="zh-TW" dirty="0">
                 <a:solidFill>
                   <a:srgbClr val="000000"/>
                 </a:solidFill>
@@ -4250,11 +4437,11 @@
                 <a:spcPts val="0"/>
               </a:spcBef>
               <a:spcAft>
-                <a:spcPts val="192"/>
+                <a:spcPts val="175"/>
               </a:spcAft>
             </a:pPr>
             <a:r>
-              <a:rPr sz="1150" b="1" lang="zh-TW" dirty="0">
+              <a:rPr sz="1050" b="1" lang="zh-TW" dirty="0">
                 <a:solidFill>
                   <a:srgbClr val="000000"/>
                 </a:solidFill>
@@ -4265,7 +4452,7 @@
               <a:t>第七列，今天新加的：雷達量不出高度。</a:t>
             </a:r>
             <a:r>
-              <a:rPr sz="1150" b="1" lang="zh-TW" dirty="0">
+              <a:rPr sz="1050" b="1" lang="zh-TW" dirty="0">
                 <a:solidFill>
                   <a:srgbClr val="000000"/>
                 </a:solidFill>
@@ -4276,15 +4463,15 @@
               <a:t>光達</a:t>
             </a:r>
             <a:r>
-              <a:rPr sz="1150" lang="zh-TW" dirty="0">
-                <a:solidFill>
-                  <a:srgbClr val="000000"/>
-                </a:solidFill>
-                <a:latin typeface="Arial Unicode MS"/>
-                <a:ea typeface="Arial Unicode MS"/>
-                <a:cs typeface="Arial Unicode MS"/>
-              </a:rPr>
-              <a:t>。任務一看到，雷達點全部被放在同一個高度，沒有一個在高處；光達的點一層一層的，有高有低，三十二條雷射線，每一條都有自己往上或往下的角度。
+              <a:rPr sz="1050" lang="zh-TW" dirty="0">
+                <a:solidFill>
+                  <a:srgbClr val="000000"/>
+                </a:solidFill>
+                <a:latin typeface="Arial Unicode MS"/>
+                <a:ea typeface="Arial Unicode MS"/>
+                <a:cs typeface="Arial Unicode MS"/>
+              </a:rPr>
+              <a:t>。任務一看到，雷達點全部被放在同一個高度，沒有一個在高處；光達的點一層一層的，有高有低，三十二條雷射線，每一條都有自己往上或往下的角度。有同學會選「相機和光達」：相機看得出東西在畫面的上面還是下面，可是量不出它離地幾公尺，所以最直接的答案是光達。
 </a:t>
             </a:r>
           </a:p>
@@ -4294,11 +4481,11 @@
                 <a:spcPts val="0"/>
               </a:spcBef>
               <a:spcAft>
-                <a:spcPts val="192"/>
+                <a:spcPts val="175"/>
               </a:spcAft>
             </a:pPr>
             <a:r>
-              <a:rPr sz="1150" b="1" lang="zh-TW" dirty="0">
+              <a:rPr sz="1050" b="1" lang="zh-TW" dirty="0">
                 <a:solidFill>
                   <a:srgbClr val="000000"/>
                 </a:solidFill>
@@ -4309,7 +4496,7 @@
               <a:t>第八列，今天新加的：雷達很少抓到行人和機車。</a:t>
             </a:r>
             <a:r>
-              <a:rPr sz="1150" b="1" lang="zh-TW" dirty="0">
+              <a:rPr sz="1050" b="1" lang="zh-TW" dirty="0">
                 <a:solidFill>
                   <a:srgbClr val="000000"/>
                 </a:solidFill>
@@ -4320,7 +4507,7 @@
               <a:t>相機和光達</a:t>
             </a:r>
             <a:r>
-              <a:rPr sz="1150" lang="zh-TW" dirty="0">
+              <a:rPr sz="1050" lang="zh-TW" dirty="0">
                 <a:solidFill>
                   <a:srgbClr val="000000"/>
                 </a:solidFill>
@@ -4338,11 +4525,11 @@
                 <a:spcPts val="0"/>
               </a:spcBef>
               <a:spcAft>
-                <a:spcPts val="192"/>
+                <a:spcPts val="175"/>
               </a:spcAft>
             </a:pPr>
             <a:r>
-              <a:rPr sz="1150" lang="zh-TW" dirty="0">
+              <a:rPr sz="1050" lang="zh-TW" dirty="0">
                 <a:solidFill>
                   <a:srgbClr val="000000"/>
                 </a:solidFill>
@@ -9392,7 +9579,7 @@
         <p:spPr>
           <a:xfrm>
             <a:off x="502920" y="1101852"/>
-            <a:ext cx="4206240" cy="2514600"/>
+            <a:ext cx="4006735" cy="2514600"/>
           </a:xfrm>
           <a:prstGeom prst="roundRect">
             <a:avLst>
@@ -9426,8 +9613,8 @@
         </p:blipFill>
         <p:spPr>
           <a:xfrm>
-            <a:off x="576072" y="1252728"/>
-            <a:ext cx="4059936" cy="2029968"/>
+            <a:off x="576072" y="1206094"/>
+            <a:ext cx="3860431" cy="2123237"/>
           </a:xfrm>
           <a:prstGeom prst="rect">
             <a:avLst/>
@@ -9443,7 +9630,7 @@
         <p:spPr>
           <a:xfrm>
             <a:off x="576072" y="3396996"/>
-            <a:ext cx="4059936" cy="182880"/>
+            <a:ext cx="3860431" cy="182880"/>
           </a:xfrm>
           <a:prstGeom prst="rect">
             <a:avLst/>
@@ -9481,8 +9668,8 @@
         </p:nvSpPr>
         <p:spPr>
           <a:xfrm>
-            <a:off x="5020056" y="914400"/>
-            <a:ext cx="3621024" cy="2889504"/>
+            <a:off x="4820551" y="914400"/>
+            <a:ext cx="3820529" cy="2889504"/>
           </a:xfrm>
           <a:prstGeom prst="rect">
             <a:avLst/>
@@ -9641,7 +9828,7 @@
                 <a:ea typeface="Arial" pitchFamily="34" charset="-122"/>
                 <a:cs typeface="Arial" pitchFamily="34" charset="-120"/>
               </a:rPr>
-              <a:t>Bảng có mọi vật trong 50 m, kể cả phía sau. Hỏi «trong camera trước» thì chỉ đếm dòng có ●.</a:t>
+              <a:t>Bảng mặc định chỉ có vật trong camera trước; nút «Tất cả quanh xe» mở cả vật phía sau, bên hông.</a:t>
             </a:r>
             <a:endParaRPr lang="en-US" sz="1250" dirty="0"/>
           </a:p>
@@ -9661,7 +9848,7 @@
                 <a:ea typeface="微軟正黑體" pitchFamily="34" charset="-122"/>
                 <a:cs typeface="微軟正黑體" pitchFamily="34" charset="-120"/>
               </a:rPr>
-              <a:t>表格列出周圍 50 公尺內全部物體，連後面的也算。問「前方相機畫面裡」，只數有 ● 的。</a:t>
+              <a:t>表格預設只列前方相機畫面裡的；按「周圍一圈全部」，連旁邊、後面的也列出來。</a:t>
             </a:r>
             <a:endParaRPr lang="en-US" sz="1250" dirty="0"/>
           </a:p>
@@ -11020,7 +11207,7 @@
                 <a:ea typeface="Arial" pitchFamily="34" charset="-122"/>
                 <a:cs typeface="Arial" pitchFamily="34" charset="-120"/>
               </a:rPr>
-              <a:t>Chọn «Bãi đỗ xe», mở hộp. Bãi đỗ có rất nhiều xe: chỉ đếm dòng có dấu ●.</a:t>
+              <a:t>Chọn «Bãi đỗ xe», mở hộp. Bảng có 17 dòng: nhớ cuộn xuống hết.</a:t>
             </a:r>
             <a:endParaRPr lang="en-US" sz="1250" dirty="0"/>
           </a:p>
@@ -11040,7 +11227,7 @@
                 <a:ea typeface="微軟正黑體" pitchFamily="34" charset="-122"/>
                 <a:cs typeface="微軟正黑體" pitchFamily="34" charset="-120"/>
               </a:rPr>
-              <a:t>場景選「停車場」，打開物體框。停車場的車很多：只數有 ● 的那幾列。</a:t>
+              <a:t>場景選「停車場」，打開物體框。表格有 17 列，記得往下捲到底。</a:t>
             </a:r>
             <a:endParaRPr lang="en-US" sz="1250" dirty="0"/>
           </a:p>
@@ -12776,7 +12963,7 @@
                 <a:ea typeface="Arial" pitchFamily="34" charset="-122"/>
                 <a:cs typeface="Arial" pitchFamily="34" charset="-120"/>
               </a:rPr>
-              <a:t>Câu 11: «một ô tô», «12 m», «18 km/h ra xa» — mỗi phần dựa vào ai?</a:t>
+              <a:t>Câu 11: «một ô tô», «12 m», «chạy ra xa 18 km/h» — mỗi phần dựa vào ai?</a:t>
             </a:r>
             <a:endParaRPr lang="en-US" sz="1250" dirty="0"/>
           </a:p>
@@ -12796,7 +12983,7 @@
                 <a:ea typeface="微軟正黑體" pitchFamily="34" charset="-122"/>
                 <a:cs typeface="微軟正黑體" pitchFamily="34" charset="-120"/>
               </a:rPr>
-              <a:t>第 11 題：「一台車」「12 公尺」「時速 18 遠離」，分別最靠誰？</a:t>
+              <a:t>第 11 題：「一台車」「12 公尺」「時速 18 往遠處開」，分別最靠誰？</a:t>
             </a:r>
             <a:endParaRPr lang="en-US" sz="1250" dirty="0"/>
           </a:p>

</xml_diff>